<commit_message>
Updated templates and PPT for StyleCart
</commit_message>
<xml_diff>
--- a/Docs/Co-Po Report PPT (StyleCart).pptx
+++ b/Docs/Co-Po Report PPT (StyleCart).pptx
@@ -5,7 +5,7 @@
     <p:sldMasterId id="2147483648" r:id="rId1"/>
   </p:sldMasterIdLst>
   <p:notesMasterIdLst>
-    <p:notesMasterId r:id="rId10"/>
+    <p:notesMasterId r:id="rId13"/>
   </p:notesMasterIdLst>
   <p:sldIdLst>
     <p:sldId id="256" r:id="rId2"/>
@@ -14,8 +14,11 @@
     <p:sldId id="258" r:id="rId5"/>
     <p:sldId id="259" r:id="rId6"/>
     <p:sldId id="260" r:id="rId7"/>
-    <p:sldId id="261" r:id="rId8"/>
-    <p:sldId id="262" r:id="rId9"/>
+    <p:sldId id="264" r:id="rId8"/>
+    <p:sldId id="265" r:id="rId9"/>
+    <p:sldId id="266" r:id="rId10"/>
+    <p:sldId id="261" r:id="rId11"/>
+    <p:sldId id="262" r:id="rId12"/>
   </p:sldIdLst>
   <p:sldSz cx="9144000" cy="6858000" type="screen4x3"/>
   <p:notesSz cx="6858000" cy="9144000"/>
@@ -1119,7 +1122,7 @@
           </a:ln>
           <a:extLst>
             <a:ext uri="{C572A759-6A51-4108-AA02-DFA0A04FC94B}">
-              <ma14:wrappingTextBoxFlag xmlns="" xmlns:m="http://schemas.openxmlformats.org/officeDocument/2006/math" xmlns:a14="http://schemas.microsoft.com/office/drawing/2010/main" xmlns:ma14="http://schemas.microsoft.com/office/mac/drawingml/2011/main" val="1"/>
+              <ma14:wrappingTextBoxFlag xmlns:ma14="http://schemas.microsoft.com/office/mac/drawingml/2011/main" xmlns:a14="http://schemas.microsoft.com/office/drawing/2010/main" xmlns:m="http://schemas.openxmlformats.org/officeDocument/2006/math" xmlns="" val="1"/>
             </a:ext>
           </a:extLst>
         </p:spPr>
@@ -1158,7 +1161,7 @@
           </a:ln>
           <a:extLst>
             <a:ext uri="{C572A759-6A51-4108-AA02-DFA0A04FC94B}">
-              <ma14:wrappingTextBoxFlag xmlns="" xmlns:m="http://schemas.openxmlformats.org/officeDocument/2006/math" xmlns:a14="http://schemas.microsoft.com/office/drawing/2010/main" xmlns:ma14="http://schemas.microsoft.com/office/mac/drawingml/2011/main" val="1"/>
+              <ma14:wrappingTextBoxFlag xmlns:ma14="http://schemas.microsoft.com/office/mac/drawingml/2011/main" xmlns:a14="http://schemas.microsoft.com/office/drawing/2010/main" xmlns:m="http://schemas.openxmlformats.org/officeDocument/2006/math" xmlns="" val="1"/>
             </a:ext>
           </a:extLst>
         </p:spPr>
@@ -2019,7 +2022,7 @@
           </a:ln>
           <a:extLst>
             <a:ext uri="{C572A759-6A51-4108-AA02-DFA0A04FC94B}">
-              <ma14:wrappingTextBoxFlag xmlns="" xmlns:m="http://schemas.openxmlformats.org/officeDocument/2006/math" xmlns:a14="http://schemas.microsoft.com/office/drawing/2010/main" xmlns:ma14="http://schemas.microsoft.com/office/mac/drawingml/2011/main" val="1"/>
+              <ma14:wrappingTextBoxFlag xmlns:ma14="http://schemas.microsoft.com/office/mac/drawingml/2011/main" xmlns:a14="http://schemas.microsoft.com/office/drawing/2010/main" xmlns:m="http://schemas.openxmlformats.org/officeDocument/2006/math" xmlns="" val="1"/>
             </a:ext>
           </a:extLst>
         </p:spPr>
@@ -2067,7 +2070,7 @@
           </a:prstGeom>
           <a:extLst>
             <a:ext uri="{C572A759-6A51-4108-AA02-DFA0A04FC94B}">
-              <ma14:wrappingTextBoxFlag xmlns="" xmlns:m="http://schemas.openxmlformats.org/officeDocument/2006/math" xmlns:a14="http://schemas.microsoft.com/office/drawing/2010/main" xmlns:ma14="http://schemas.microsoft.com/office/mac/drawingml/2011/main" val="1"/>
+              <ma14:wrappingTextBoxFlag xmlns:ma14="http://schemas.microsoft.com/office/mac/drawingml/2011/main" xmlns:a14="http://schemas.microsoft.com/office/drawing/2010/main" xmlns:m="http://schemas.openxmlformats.org/officeDocument/2006/math" xmlns="" val="1"/>
             </a:ext>
           </a:extLst>
         </p:spPr>
@@ -2102,7 +2105,7 @@
           </a:ln>
           <a:extLst>
             <a:ext uri="{C572A759-6A51-4108-AA02-DFA0A04FC94B}">
-              <ma14:wrappingTextBoxFlag xmlns="" xmlns:m="http://schemas.openxmlformats.org/officeDocument/2006/math" xmlns:a14="http://schemas.microsoft.com/office/drawing/2010/main" xmlns:ma14="http://schemas.microsoft.com/office/mac/drawingml/2011/main" val="1"/>
+              <ma14:wrappingTextBoxFlag xmlns:ma14="http://schemas.microsoft.com/office/mac/drawingml/2011/main" xmlns:a14="http://schemas.microsoft.com/office/drawing/2010/main" xmlns:m="http://schemas.openxmlformats.org/officeDocument/2006/math" xmlns="" val="1"/>
             </a:ext>
           </a:extLst>
         </p:spPr>
@@ -2576,6 +2579,869 @@
               </a:rPr>
               <a:t>Chitkara University, Punjab</a:t>
             </a:r>
+          </a:p>
+        </p:txBody>
+      </p:sp>
+    </p:spTree>
+  </p:cSld>
+  <p:clrMapOvr>
+    <a:masterClrMapping/>
+  </p:clrMapOvr>
+  <p:transition spd="med"/>
+</p:sld>
+</file>
+
+<file path=ppt/slides/slide10.xml><?xml version="1.0" encoding="utf-8"?>
+<p:sld xmlns:a="http://schemas.openxmlformats.org/drawingml/2006/main" xmlns:r="http://schemas.openxmlformats.org/officeDocument/2006/relationships" xmlns:p="http://schemas.openxmlformats.org/presentationml/2006/main">
+  <p:cSld>
+    <p:spTree>
+      <p:nvGrpSpPr>
+        <p:cNvPr id="1" name=""/>
+        <p:cNvGrpSpPr/>
+        <p:nvPr/>
+      </p:nvGrpSpPr>
+      <p:grpSpPr>
+        <a:xfrm>
+          <a:off x="0" y="0"/>
+          <a:ext cx="0" cy="0"/>
+          <a:chOff x="0" y="0"/>
+          <a:chExt cx="0" cy="0"/>
+        </a:xfrm>
+      </p:grpSpPr>
+      <p:sp>
+        <p:nvSpPr>
+          <p:cNvPr id="71" name="Google Shape;46;p1"/>
+          <p:cNvSpPr txBox="1"/>
+          <p:nvPr/>
+        </p:nvSpPr>
+        <p:spPr>
+          <a:xfrm>
+            <a:off x="502925" y="6414780"/>
+            <a:ext cx="2042150" cy="248265"/>
+          </a:xfrm>
+          <a:prstGeom prst="rect">
+            <a:avLst/>
+          </a:prstGeom>
+          <a:ln w="12700">
+            <a:miter lim="400000"/>
+          </a:ln>
+          <a:extLst>
+            <a:ext uri="{C572A759-6A51-4108-AA02-DFA0A04FC94B}">
+              <ma14:wrappingTextBoxFlag xmlns:ma14="http://schemas.microsoft.com/office/mac/drawingml/2011/main" xmlns:a14="http://schemas.microsoft.com/office/drawing/2010/main" xmlns:m="http://schemas.openxmlformats.org/officeDocument/2006/math" xmlns="" val="1"/>
+            </a:ext>
+          </a:extLst>
+        </p:spPr>
+        <p:txBody>
+          <a:bodyPr lIns="45699" tIns="45699" rIns="45699" bIns="45699" anchor="ctr">
+            <a:spAutoFit/>
+          </a:bodyPr>
+          <a:lstStyle>
+            <a:lvl1pPr>
+              <a:defRPr sz="1200">
+                <a:solidFill>
+                  <a:srgbClr val="898989"/>
+                </a:solidFill>
+                <a:latin typeface="Calibri"/>
+                <a:ea typeface="Calibri"/>
+                <a:cs typeface="Calibri"/>
+                <a:sym typeface="Calibri"/>
+              </a:defRPr>
+            </a:lvl1pPr>
+          </a:lstStyle>
+          <a:p>
+            <a:r>
+              <a:t>22CS026</a:t>
+            </a:r>
+          </a:p>
+        </p:txBody>
+      </p:sp>
+      <p:sp>
+        <p:nvSpPr>
+          <p:cNvPr id="72" name="Google Shape;47;p1"/>
+          <p:cNvSpPr txBox="1">
+            <a:spLocks noGrp="1"/>
+          </p:cNvSpPr>
+          <p:nvPr>
+            <p:ph type="sldNum" sz="quarter" idx="2"/>
+          </p:nvPr>
+        </p:nvSpPr>
+        <p:spPr>
+          <a:xfrm>
+            <a:off x="8505458" y="6414780"/>
+            <a:ext cx="181343" cy="248265"/>
+          </a:xfrm>
+          <a:prstGeom prst="rect">
+            <a:avLst/>
+          </a:prstGeom>
+          <a:extLst>
+            <a:ext uri="{C572A759-6A51-4108-AA02-DFA0A04FC94B}">
+              <ma14:wrappingTextBoxFlag xmlns:ma14="http://schemas.microsoft.com/office/mac/drawingml/2011/main" xmlns:a14="http://schemas.microsoft.com/office/drawing/2010/main" xmlns:m="http://schemas.openxmlformats.org/officeDocument/2006/math" xmlns="" val="1"/>
+            </a:ext>
+          </a:extLst>
+        </p:spPr>
+        <p:txBody>
+          <a:bodyPr/>
+          <a:lstStyle/>
+          <a:p>
+            <a:fld id="{86CB4B4D-7CA3-9044-876B-883B54F8677D}" type="slidenum">
+              <a:rPr/>
+              <a:t>10</a:t>
+            </a:fld>
+            <a:endParaRPr/>
+          </a:p>
+        </p:txBody>
+      </p:sp>
+      <p:sp>
+        <p:nvSpPr>
+          <p:cNvPr id="73" name="Google Shape;48;p1"/>
+          <p:cNvSpPr txBox="1"/>
+          <p:nvPr/>
+        </p:nvSpPr>
+        <p:spPr>
+          <a:xfrm>
+            <a:off x="58325" y="2338162"/>
+            <a:ext cx="9027350" cy="2872306"/>
+          </a:xfrm>
+          <a:prstGeom prst="rect">
+            <a:avLst/>
+          </a:prstGeom>
+          <a:ln w="12700">
+            <a:miter lim="400000"/>
+          </a:ln>
+          <a:extLst>
+            <a:ext uri="{C572A759-6A51-4108-AA02-DFA0A04FC94B}">
+              <ma14:wrappingTextBoxFlag xmlns:ma14="http://schemas.microsoft.com/office/mac/drawingml/2011/main" xmlns:a14="http://schemas.microsoft.com/office/drawing/2010/main" xmlns:m="http://schemas.openxmlformats.org/officeDocument/2006/math" xmlns="" val="1"/>
+            </a:ext>
+          </a:extLst>
+        </p:spPr>
+        <p:txBody>
+          <a:bodyPr lIns="33099" tIns="33099" rIns="33099" bIns="33099" anchor="ctr">
+            <a:spAutoFit/>
+          </a:bodyPr>
+          <a:lstStyle/>
+          <a:p>
+            <a:pPr algn="ctr">
+              <a:defRPr sz="3200" b="1">
+                <a:solidFill>
+                  <a:srgbClr val="FF0000"/>
+                </a:solidFill>
+              </a:defRPr>
+            </a:pPr>
+            <a:endParaRPr/>
+          </a:p>
+          <a:p>
+            <a:pPr algn="ctr">
+              <a:defRPr sz="3200" b="1">
+                <a:solidFill>
+                  <a:srgbClr val="FF0000"/>
+                </a:solidFill>
+              </a:defRPr>
+            </a:pPr>
+            <a:endParaRPr/>
+          </a:p>
+          <a:p>
+            <a:pPr algn="ctr">
+              <a:defRPr sz="3200" b="1">
+                <a:solidFill>
+                  <a:srgbClr val="FF0000"/>
+                </a:solidFill>
+              </a:defRPr>
+            </a:pPr>
+            <a:endParaRPr/>
+          </a:p>
+          <a:p>
+            <a:pPr algn="ctr">
+              <a:defRPr sz="3200" b="1">
+                <a:solidFill>
+                  <a:srgbClr val="FF0000"/>
+                </a:solidFill>
+              </a:defRPr>
+            </a:pPr>
+            <a:br/>
+            <a:endParaRPr/>
+          </a:p>
+        </p:txBody>
+      </p:sp>
+      <p:sp>
+        <p:nvSpPr>
+          <p:cNvPr id="74" name="TextBox 1"/>
+          <p:cNvSpPr txBox="1"/>
+          <p:nvPr/>
+        </p:nvSpPr>
+        <p:spPr>
+          <a:xfrm>
+            <a:off x="2814359" y="1051421"/>
+            <a:ext cx="3660761" cy="510777"/>
+          </a:xfrm>
+          <a:prstGeom prst="rect">
+            <a:avLst/>
+          </a:prstGeom>
+          <a:ln w="12700">
+            <a:miter lim="400000"/>
+          </a:ln>
+          <a:extLst>
+            <a:ext uri="{C572A759-6A51-4108-AA02-DFA0A04FC94B}">
+              <ma14:wrappingTextBoxFlag xmlns:ma14="http://schemas.microsoft.com/office/mac/drawingml/2011/main" xmlns:a14="http://schemas.microsoft.com/office/drawing/2010/main" xmlns:m="http://schemas.openxmlformats.org/officeDocument/2006/math" xmlns="" val="1"/>
+            </a:ext>
+          </a:extLst>
+        </p:spPr>
+        <p:txBody>
+          <a:bodyPr wrap="none" lIns="45719" rIns="45719">
+            <a:spAutoFit/>
+          </a:bodyPr>
+          <a:lstStyle>
+            <a:lvl1pPr>
+              <a:defRPr sz="3000" b="1"/>
+            </a:lvl1pPr>
+          </a:lstStyle>
+          <a:p>
+            <a:r>
+              <a:t>Upcoming Features</a:t>
+            </a:r>
+          </a:p>
+        </p:txBody>
+      </p:sp>
+      <p:sp>
+        <p:nvSpPr>
+          <p:cNvPr id="75" name="Rectangle 1"/>
+          <p:cNvSpPr txBox="1"/>
+          <p:nvPr/>
+        </p:nvSpPr>
+        <p:spPr>
+          <a:xfrm>
+            <a:off x="534323" y="2971532"/>
+            <a:ext cx="7585148" cy="276999"/>
+          </a:xfrm>
+          <a:prstGeom prst="rect">
+            <a:avLst/>
+          </a:prstGeom>
+          <a:ln w="12700">
+            <a:miter lim="400000"/>
+          </a:ln>
+          <a:extLst>
+            <a:ext uri="{C572A759-6A51-4108-AA02-DFA0A04FC94B}">
+              <ma14:wrappingTextBoxFlag xmlns:ma14="http://schemas.microsoft.com/office/mac/drawingml/2011/main" xmlns:a14="http://schemas.microsoft.com/office/drawing/2010/main" xmlns:m="http://schemas.openxmlformats.org/officeDocument/2006/math" xmlns="" val="1"/>
+            </a:ext>
+          </a:extLst>
+        </p:spPr>
+        <p:txBody>
+          <a:bodyPr lIns="45719" rIns="45719" anchor="ctr">
+            <a:spAutoFit/>
+          </a:bodyPr>
+          <a:lstStyle/>
+          <a:p>
+            <a:pPr defTabSz="457200">
+              <a:spcBef>
+                <a:spcPts val="1200"/>
+              </a:spcBef>
+              <a:defRPr sz="1200">
+                <a:latin typeface="Times Roman"/>
+                <a:ea typeface="Times Roman"/>
+                <a:cs typeface="Times Roman"/>
+                <a:sym typeface="Times Roman"/>
+              </a:defRPr>
+            </a:pPr>
+            <a:endParaRPr dirty="0"/>
+          </a:p>
+        </p:txBody>
+      </p:sp>
+      <p:sp>
+        <p:nvSpPr>
+          <p:cNvPr id="2" name="Rectangle 1">
+            <a:extLst>
+              <a:ext uri="{FF2B5EF4-FFF2-40B4-BE49-F238E27FC236}">
+                <a16:creationId xmlns:a16="http://schemas.microsoft.com/office/drawing/2014/main" id="{715BB1B9-DEE5-2D69-1FC8-F37E11895D5F}"/>
+              </a:ext>
+            </a:extLst>
+          </p:cNvPr>
+          <p:cNvSpPr>
+            <a:spLocks noChangeArrowheads="1"/>
+          </p:cNvSpPr>
+          <p:nvPr/>
+        </p:nvSpPr>
+        <p:spPr bwMode="auto">
+          <a:xfrm>
+            <a:off x="402335" y="2274839"/>
+            <a:ext cx="7717135" cy="2308324"/>
+          </a:xfrm>
+          <a:prstGeom prst="rect">
+            <a:avLst/>
+          </a:prstGeom>
+          <a:noFill/>
+          <a:ln>
+            <a:noFill/>
+          </a:ln>
+          <a:effectLst/>
+          <a:extLst>
+            <a:ext uri="{909E8E84-426E-40DD-AFC4-6F175D3DCCD1}">
+              <a14:hiddenFill xmlns:a14="http://schemas.microsoft.com/office/drawing/2010/main">
+                <a:solidFill>
+                  <a:schemeClr val="accent1"/>
+                </a:solidFill>
+              </a14:hiddenFill>
+            </a:ext>
+            <a:ext uri="{91240B29-F687-4F45-9708-019B960494DF}">
+              <a14:hiddenLine xmlns:a14="http://schemas.microsoft.com/office/drawing/2010/main" w="9525">
+                <a:solidFill>
+                  <a:schemeClr val="tx1"/>
+                </a:solidFill>
+                <a:miter lim="800000"/>
+                <a:headEnd/>
+                <a:tailEnd/>
+              </a14:hiddenLine>
+            </a:ext>
+            <a:ext uri="{AF507438-7753-43E0-B8FC-AC1667EBCBE1}">
+              <a14:hiddenEffects xmlns:a14="http://schemas.microsoft.com/office/drawing/2010/main">
+                <a:effectLst>
+                  <a:outerShdw dist="35921" dir="2700000" algn="ctr" rotWithShape="0">
+                    <a:schemeClr val="bg2"/>
+                  </a:outerShdw>
+                </a:effectLst>
+              </a14:hiddenEffects>
+            </a:ext>
+          </a:extLst>
+        </p:spPr>
+        <p:txBody>
+          <a:bodyPr vert="horz" wrap="square" lIns="91440" tIns="45720" rIns="91440" bIns="45720" numCol="1" anchor="ctr" anchorCtr="0" compatLnSpc="1">
+            <a:prstTxWarp prst="textNoShape">
+              <a:avLst/>
+            </a:prstTxWarp>
+            <a:spAutoFit/>
+          </a:bodyPr>
+          <a:lstStyle/>
+          <a:p>
+            <a:pPr marL="0" marR="0" lvl="0" indent="0" algn="l" defTabSz="914400" rtl="0" eaLnBrk="0" fontAlgn="base" latinLnBrk="0" hangingPunct="0">
+              <a:lnSpc>
+                <a:spcPct val="100000"/>
+              </a:lnSpc>
+              <a:spcBef>
+                <a:spcPct val="0"/>
+              </a:spcBef>
+              <a:spcAft>
+                <a:spcPct val="0"/>
+              </a:spcAft>
+              <a:buClrTx/>
+              <a:buSzTx/>
+              <a:buFontTx/>
+              <a:buChar char="•"/>
+              <a:tabLst/>
+            </a:pPr>
+            <a:r>
+              <a:rPr kumimoji="0" lang="en-US" altLang="en-US" sz="1800" b="1" i="0" u="none" strike="noStrike" cap="none" normalizeH="0" baseline="0" dirty="0">
+                <a:ln>
+                  <a:noFill/>
+                </a:ln>
+                <a:solidFill>
+                  <a:schemeClr val="tx1"/>
+                </a:solidFill>
+                <a:effectLst/>
+                <a:latin typeface="Arial" panose="020B0604020202020204" pitchFamily="34" charset="0"/>
+              </a:rPr>
+              <a:t>Payment Gateway Integration</a:t>
+            </a:r>
+            <a:br>
+              <a:rPr kumimoji="0" lang="en-US" altLang="en-US" sz="1800" b="0" i="0" u="none" strike="noStrike" cap="none" normalizeH="0" baseline="0" dirty="0">
+                <a:ln>
+                  <a:noFill/>
+                </a:ln>
+                <a:solidFill>
+                  <a:schemeClr val="tx1"/>
+                </a:solidFill>
+                <a:effectLst/>
+                <a:latin typeface="Arial" panose="020B0604020202020204" pitchFamily="34" charset="0"/>
+              </a:rPr>
+            </a:br>
+            <a:r>
+              <a:rPr kumimoji="0" lang="en-US" altLang="en-US" sz="1800" b="0" i="0" u="none" strike="noStrike" cap="none" normalizeH="0" baseline="0" dirty="0">
+                <a:ln>
+                  <a:noFill/>
+                </a:ln>
+                <a:solidFill>
+                  <a:schemeClr val="tx1"/>
+                </a:solidFill>
+                <a:effectLst/>
+                <a:latin typeface="Arial" panose="020B0604020202020204" pitchFamily="34" charset="0"/>
+              </a:rPr>
+              <a:t>Integration with UPI for online payments</a:t>
+            </a:r>
+          </a:p>
+          <a:p>
+            <a:pPr marL="0" marR="0" lvl="0" indent="0" algn="l" defTabSz="914400" rtl="0" eaLnBrk="0" fontAlgn="base" latinLnBrk="0" hangingPunct="0">
+              <a:lnSpc>
+                <a:spcPct val="100000"/>
+              </a:lnSpc>
+              <a:spcBef>
+                <a:spcPct val="0"/>
+              </a:spcBef>
+              <a:spcAft>
+                <a:spcPct val="0"/>
+              </a:spcAft>
+              <a:buClrTx/>
+              <a:buSzTx/>
+              <a:tabLst/>
+            </a:pPr>
+            <a:r>
+              <a:rPr kumimoji="0" lang="en-US" altLang="en-US" sz="1800" b="0" i="0" u="none" strike="noStrike" cap="none" normalizeH="0" baseline="0" dirty="0">
+                <a:ln>
+                  <a:noFill/>
+                </a:ln>
+                <a:solidFill>
+                  <a:schemeClr val="tx1"/>
+                </a:solidFill>
+                <a:effectLst/>
+                <a:latin typeface="Arial" panose="020B0604020202020204" pitchFamily="34" charset="0"/>
+              </a:rPr>
+              <a:t> </a:t>
+            </a:r>
+          </a:p>
+          <a:p>
+            <a:pPr marL="0" marR="0" lvl="0" indent="0" algn="l" defTabSz="914400" rtl="0" eaLnBrk="0" fontAlgn="base" latinLnBrk="0" hangingPunct="0">
+              <a:lnSpc>
+                <a:spcPct val="100000"/>
+              </a:lnSpc>
+              <a:spcBef>
+                <a:spcPct val="0"/>
+              </a:spcBef>
+              <a:spcAft>
+                <a:spcPct val="0"/>
+              </a:spcAft>
+              <a:buClrTx/>
+              <a:buSzTx/>
+              <a:buFontTx/>
+              <a:buChar char="•"/>
+              <a:tabLst/>
+            </a:pPr>
+            <a:r>
+              <a:rPr kumimoji="0" lang="en-US" altLang="en-US" sz="1800" b="1" i="0" u="none" strike="noStrike" cap="none" normalizeH="0" baseline="0" dirty="0">
+                <a:ln>
+                  <a:noFill/>
+                </a:ln>
+                <a:solidFill>
+                  <a:schemeClr val="tx1"/>
+                </a:solidFill>
+                <a:effectLst/>
+                <a:latin typeface="Arial" panose="020B0604020202020204" pitchFamily="34" charset="0"/>
+              </a:rPr>
+              <a:t>User Authentication System</a:t>
+            </a:r>
+            <a:br>
+              <a:rPr kumimoji="0" lang="en-US" altLang="en-US" sz="1800" b="0" i="0" u="none" strike="noStrike" cap="none" normalizeH="0" baseline="0" dirty="0">
+                <a:ln>
+                  <a:noFill/>
+                </a:ln>
+                <a:solidFill>
+                  <a:schemeClr val="tx1"/>
+                </a:solidFill>
+                <a:effectLst/>
+                <a:latin typeface="Arial" panose="020B0604020202020204" pitchFamily="34" charset="0"/>
+              </a:rPr>
+            </a:br>
+            <a:r>
+              <a:rPr kumimoji="0" lang="en-US" altLang="en-US" sz="1800" b="0" i="0" u="none" strike="noStrike" cap="none" normalizeH="0" baseline="0" dirty="0">
+                <a:ln>
+                  <a:noFill/>
+                </a:ln>
+                <a:solidFill>
+                  <a:schemeClr val="tx1"/>
+                </a:solidFill>
+                <a:effectLst/>
+                <a:latin typeface="Arial" panose="020B0604020202020204" pitchFamily="34" charset="0"/>
+              </a:rPr>
+              <a:t>Login, signup, and user-specific cart</a:t>
+            </a:r>
+          </a:p>
+          <a:p>
+            <a:pPr marL="0" marR="0" lvl="0" indent="0" algn="l" defTabSz="914400" rtl="0" eaLnBrk="0" fontAlgn="base" latinLnBrk="0" hangingPunct="0">
+              <a:lnSpc>
+                <a:spcPct val="100000"/>
+              </a:lnSpc>
+              <a:spcBef>
+                <a:spcPct val="0"/>
+              </a:spcBef>
+              <a:spcAft>
+                <a:spcPct val="0"/>
+              </a:spcAft>
+              <a:buClrTx/>
+              <a:buSzTx/>
+              <a:tabLst/>
+            </a:pPr>
+            <a:r>
+              <a:rPr kumimoji="0" lang="en-US" altLang="en-US" sz="1800" b="0" i="0" u="none" strike="noStrike" cap="none" normalizeH="0" baseline="0" dirty="0">
+                <a:ln>
+                  <a:noFill/>
+                </a:ln>
+                <a:solidFill>
+                  <a:schemeClr val="tx1"/>
+                </a:solidFill>
+                <a:effectLst/>
+                <a:latin typeface="Arial" panose="020B0604020202020204" pitchFamily="34" charset="0"/>
+              </a:rPr>
+              <a:t> </a:t>
+            </a:r>
+          </a:p>
+          <a:p>
+            <a:pPr marL="0" marR="0" lvl="0" indent="0" algn="l" defTabSz="914400" rtl="0" eaLnBrk="0" fontAlgn="base" latinLnBrk="0" hangingPunct="0">
+              <a:lnSpc>
+                <a:spcPct val="100000"/>
+              </a:lnSpc>
+              <a:spcBef>
+                <a:spcPct val="0"/>
+              </a:spcBef>
+              <a:spcAft>
+                <a:spcPct val="0"/>
+              </a:spcAft>
+              <a:buClrTx/>
+              <a:buSzTx/>
+              <a:buFontTx/>
+              <a:buChar char="•"/>
+              <a:tabLst/>
+            </a:pPr>
+            <a:r>
+              <a:rPr kumimoji="0" lang="en-US" altLang="en-US" sz="1800" b="1" i="0" u="none" strike="noStrike" cap="none" normalizeH="0" baseline="0" dirty="0">
+                <a:ln>
+                  <a:noFill/>
+                </a:ln>
+                <a:solidFill>
+                  <a:schemeClr val="tx1"/>
+                </a:solidFill>
+                <a:effectLst/>
+                <a:latin typeface="Arial" panose="020B0604020202020204" pitchFamily="34" charset="0"/>
+              </a:rPr>
+              <a:t>Order Tracking System</a:t>
+            </a:r>
+            <a:br>
+              <a:rPr kumimoji="0" lang="en-US" altLang="en-US" sz="1800" b="0" i="0" u="none" strike="noStrike" cap="none" normalizeH="0" baseline="0" dirty="0">
+                <a:ln>
+                  <a:noFill/>
+                </a:ln>
+                <a:solidFill>
+                  <a:schemeClr val="tx1"/>
+                </a:solidFill>
+                <a:effectLst/>
+                <a:latin typeface="Arial" panose="020B0604020202020204" pitchFamily="34" charset="0"/>
+              </a:rPr>
+            </a:br>
+            <a:r>
+              <a:rPr kumimoji="0" lang="en-US" altLang="en-US" sz="1800" b="0" i="0" u="none" strike="noStrike" cap="none" normalizeH="0" baseline="0" dirty="0">
+                <a:ln>
+                  <a:noFill/>
+                </a:ln>
+                <a:solidFill>
+                  <a:schemeClr val="tx1"/>
+                </a:solidFill>
+                <a:effectLst/>
+                <a:latin typeface="Arial" panose="020B0604020202020204" pitchFamily="34" charset="0"/>
+              </a:rPr>
+              <a:t>Track order status after purchase </a:t>
+            </a:r>
+          </a:p>
+        </p:txBody>
+      </p:sp>
+    </p:spTree>
+  </p:cSld>
+  <p:clrMapOvr>
+    <a:masterClrMapping/>
+  </p:clrMapOvr>
+  <p:transition spd="med"/>
+</p:sld>
+</file>
+
+<file path=ppt/slides/slide11.xml><?xml version="1.0" encoding="utf-8"?>
+<p:sld xmlns:a="http://schemas.openxmlformats.org/drawingml/2006/main" xmlns:r="http://schemas.openxmlformats.org/officeDocument/2006/relationships" xmlns:p="http://schemas.openxmlformats.org/presentationml/2006/main">
+  <p:cSld>
+    <p:spTree>
+      <p:nvGrpSpPr>
+        <p:cNvPr id="1" name=""/>
+        <p:cNvGrpSpPr/>
+        <p:nvPr/>
+      </p:nvGrpSpPr>
+      <p:grpSpPr>
+        <a:xfrm>
+          <a:off x="0" y="0"/>
+          <a:ext cx="0" cy="0"/>
+          <a:chOff x="0" y="0"/>
+          <a:chExt cx="0" cy="0"/>
+        </a:xfrm>
+      </p:grpSpPr>
+      <p:sp>
+        <p:nvSpPr>
+          <p:cNvPr id="77" name="Google Shape;46;p1"/>
+          <p:cNvSpPr txBox="1"/>
+          <p:nvPr/>
+        </p:nvSpPr>
+        <p:spPr>
+          <a:xfrm>
+            <a:off x="502925" y="6414780"/>
+            <a:ext cx="2042150" cy="248265"/>
+          </a:xfrm>
+          <a:prstGeom prst="rect">
+            <a:avLst/>
+          </a:prstGeom>
+          <a:ln w="12700">
+            <a:miter lim="400000"/>
+          </a:ln>
+          <a:extLst>
+            <a:ext uri="{C572A759-6A51-4108-AA02-DFA0A04FC94B}">
+              <ma14:wrappingTextBoxFlag xmlns:ma14="http://schemas.microsoft.com/office/mac/drawingml/2011/main" xmlns:a14="http://schemas.microsoft.com/office/drawing/2010/main" xmlns:m="http://schemas.openxmlformats.org/officeDocument/2006/math" xmlns="" val="1"/>
+            </a:ext>
+          </a:extLst>
+        </p:spPr>
+        <p:txBody>
+          <a:bodyPr lIns="45699" tIns="45699" rIns="45699" bIns="45699" anchor="ctr">
+            <a:spAutoFit/>
+          </a:bodyPr>
+          <a:lstStyle>
+            <a:lvl1pPr>
+              <a:defRPr sz="1200">
+                <a:solidFill>
+                  <a:srgbClr val="898989"/>
+                </a:solidFill>
+                <a:latin typeface="Calibri"/>
+                <a:ea typeface="Calibri"/>
+                <a:cs typeface="Calibri"/>
+                <a:sym typeface="Calibri"/>
+              </a:defRPr>
+            </a:lvl1pPr>
+          </a:lstStyle>
+          <a:p>
+            <a:r>
+              <a:t>22CS026</a:t>
+            </a:r>
+          </a:p>
+        </p:txBody>
+      </p:sp>
+      <p:sp>
+        <p:nvSpPr>
+          <p:cNvPr id="78" name="Google Shape;47;p1"/>
+          <p:cNvSpPr txBox="1">
+            <a:spLocks noGrp="1"/>
+          </p:cNvSpPr>
+          <p:nvPr>
+            <p:ph type="sldNum" sz="quarter" idx="2"/>
+          </p:nvPr>
+        </p:nvSpPr>
+        <p:spPr>
+          <a:xfrm>
+            <a:off x="8505458" y="6414780"/>
+            <a:ext cx="181343" cy="248265"/>
+          </a:xfrm>
+          <a:prstGeom prst="rect">
+            <a:avLst/>
+          </a:prstGeom>
+          <a:extLst>
+            <a:ext uri="{C572A759-6A51-4108-AA02-DFA0A04FC94B}">
+              <ma14:wrappingTextBoxFlag xmlns:ma14="http://schemas.microsoft.com/office/mac/drawingml/2011/main" xmlns:a14="http://schemas.microsoft.com/office/drawing/2010/main" xmlns:m="http://schemas.openxmlformats.org/officeDocument/2006/math" xmlns="" val="1"/>
+            </a:ext>
+          </a:extLst>
+        </p:spPr>
+        <p:txBody>
+          <a:bodyPr/>
+          <a:lstStyle/>
+          <a:p>
+            <a:fld id="{86CB4B4D-7CA3-9044-876B-883B54F8677D}" type="slidenum">
+              <a:rPr/>
+              <a:t>11</a:t>
+            </a:fld>
+            <a:endParaRPr/>
+          </a:p>
+        </p:txBody>
+      </p:sp>
+      <p:sp>
+        <p:nvSpPr>
+          <p:cNvPr id="79" name="Google Shape;48;p1"/>
+          <p:cNvSpPr txBox="1"/>
+          <p:nvPr/>
+        </p:nvSpPr>
+        <p:spPr>
+          <a:xfrm>
+            <a:off x="58325" y="2338162"/>
+            <a:ext cx="9027350" cy="2872306"/>
+          </a:xfrm>
+          <a:prstGeom prst="rect">
+            <a:avLst/>
+          </a:prstGeom>
+          <a:ln w="12700">
+            <a:miter lim="400000"/>
+          </a:ln>
+          <a:extLst>
+            <a:ext uri="{C572A759-6A51-4108-AA02-DFA0A04FC94B}">
+              <ma14:wrappingTextBoxFlag xmlns:ma14="http://schemas.microsoft.com/office/mac/drawingml/2011/main" xmlns:a14="http://schemas.microsoft.com/office/drawing/2010/main" xmlns:m="http://schemas.openxmlformats.org/officeDocument/2006/math" xmlns="" val="1"/>
+            </a:ext>
+          </a:extLst>
+        </p:spPr>
+        <p:txBody>
+          <a:bodyPr lIns="33099" tIns="33099" rIns="33099" bIns="33099" anchor="ctr">
+            <a:spAutoFit/>
+          </a:bodyPr>
+          <a:lstStyle/>
+          <a:p>
+            <a:pPr algn="ctr">
+              <a:defRPr sz="3200" b="1">
+                <a:solidFill>
+                  <a:srgbClr val="FF0000"/>
+                </a:solidFill>
+              </a:defRPr>
+            </a:pPr>
+            <a:endParaRPr/>
+          </a:p>
+          <a:p>
+            <a:pPr algn="ctr">
+              <a:defRPr sz="3200" b="1">
+                <a:solidFill>
+                  <a:srgbClr val="FF0000"/>
+                </a:solidFill>
+              </a:defRPr>
+            </a:pPr>
+            <a:endParaRPr/>
+          </a:p>
+          <a:p>
+            <a:pPr algn="ctr">
+              <a:defRPr sz="3200" b="1">
+                <a:solidFill>
+                  <a:srgbClr val="FF0000"/>
+                </a:solidFill>
+              </a:defRPr>
+            </a:pPr>
+            <a:endParaRPr/>
+          </a:p>
+          <a:p>
+            <a:pPr algn="ctr">
+              <a:defRPr sz="3200" b="1">
+                <a:solidFill>
+                  <a:srgbClr val="FF0000"/>
+                </a:solidFill>
+              </a:defRPr>
+            </a:pPr>
+            <a:br/>
+            <a:endParaRPr/>
+          </a:p>
+        </p:txBody>
+      </p:sp>
+      <p:sp>
+        <p:nvSpPr>
+          <p:cNvPr id="80" name="TextBox 3"/>
+          <p:cNvSpPr txBox="1"/>
+          <p:nvPr/>
+        </p:nvSpPr>
+        <p:spPr>
+          <a:xfrm>
+            <a:off x="502924" y="1180469"/>
+            <a:ext cx="7926737" cy="4955203"/>
+          </a:xfrm>
+          <a:prstGeom prst="rect">
+            <a:avLst/>
+          </a:prstGeom>
+          <a:ln w="12700">
+            <a:miter lim="400000"/>
+          </a:ln>
+          <a:extLst>
+            <a:ext uri="{C572A759-6A51-4108-AA02-DFA0A04FC94B}">
+              <ma14:wrappingTextBoxFlag xmlns:ma14="http://schemas.microsoft.com/office/mac/drawingml/2011/main" xmlns:a14="http://schemas.microsoft.com/office/drawing/2010/main" xmlns:m="http://schemas.openxmlformats.org/officeDocument/2006/math" xmlns="" val="1"/>
+            </a:ext>
+          </a:extLst>
+        </p:spPr>
+        <p:txBody>
+          <a:bodyPr wrap="square" lIns="45719" rIns="45719">
+            <a:spAutoFit/>
+          </a:bodyPr>
+          <a:lstStyle/>
+          <a:p>
+            <a:pPr>
+              <a:defRPr sz="2800" b="1"/>
+            </a:pPr>
+            <a:r>
+              <a:rPr dirty="0"/>
+              <a:t>                         </a:t>
+            </a:r>
+            <a:r>
+              <a:rPr sz="3000" dirty="0"/>
+              <a:t>Conclusion</a:t>
+            </a:r>
+          </a:p>
+          <a:p>
+            <a:pPr>
+              <a:defRPr sz="2800" b="1"/>
+            </a:pPr>
+            <a:endParaRPr sz="3000" dirty="0"/>
+          </a:p>
+          <a:p>
+            <a:pPr>
+              <a:defRPr sz="2000" b="1"/>
+            </a:pPr>
+            <a:r>
+              <a:rPr dirty="0"/>
+              <a:t>Summary</a:t>
+            </a:r>
+            <a:r>
+              <a:rPr b="0" dirty="0"/>
+              <a:t>:</a:t>
+            </a:r>
+          </a:p>
+          <a:p>
+            <a:pPr>
+              <a:defRPr sz="1800"/>
+            </a:pPr>
+            <a:endParaRPr b="0" dirty="0"/>
+          </a:p>
+          <a:p>
+            <a:r>
+              <a:rPr lang="en-US" sz="2000" b="1" dirty="0"/>
+              <a:t>StyleCart</a:t>
+            </a:r>
+            <a:r>
+              <a:rPr lang="en-US" sz="2000" dirty="0"/>
+              <a:t> focuses on building a functional </a:t>
+            </a:r>
+            <a:r>
+              <a:rPr lang="en-US" sz="2000" b="1" dirty="0"/>
+              <a:t>e-commerce system </a:t>
+            </a:r>
+            <a:r>
+              <a:rPr lang="en-US" sz="2000" dirty="0"/>
+              <a:t>using </a:t>
+            </a:r>
+            <a:r>
+              <a:rPr lang="en-US" sz="2000" b="1" dirty="0"/>
+              <a:t>Django</a:t>
+            </a:r>
+            <a:r>
+              <a:rPr lang="en-US" sz="2000" dirty="0"/>
+              <a:t>.</a:t>
+            </a:r>
+          </a:p>
+          <a:p>
+            <a:endParaRPr lang="en-US" sz="2000" dirty="0"/>
+          </a:p>
+          <a:p>
+            <a:r>
+              <a:rPr lang="en-US" sz="2000" dirty="0"/>
+              <a:t>It demonstrates key features such as product browsing, cart management, and backend integration.</a:t>
+            </a:r>
+          </a:p>
+          <a:p>
+            <a:endParaRPr lang="en-US" sz="2000" dirty="0"/>
+          </a:p>
+          <a:p>
+            <a:r>
+              <a:rPr lang="en-US" sz="2000" dirty="0"/>
+              <a:t>The project provides hands-on experience in full-stack development and simulates real-world online shopping platforms.</a:t>
+            </a:r>
+          </a:p>
+          <a:p>
+            <a:pPr defTabSz="457200">
+              <a:spcBef>
+                <a:spcPts val="1200"/>
+              </a:spcBef>
+            </a:pPr>
+            <a:endParaRPr sz="2000" dirty="0"/>
+          </a:p>
+          <a:p>
+            <a:pPr lvl="1" indent="457200"/>
+            <a:endParaRPr dirty="0"/>
+          </a:p>
+          <a:p>
+            <a:pPr lvl="1" indent="457200"/>
+            <a:endParaRPr dirty="0"/>
           </a:p>
         </p:txBody>
       </p:sp>
@@ -2965,7 +3831,7 @@
           </a:ln>
           <a:extLst>
             <a:ext uri="{C572A759-6A51-4108-AA02-DFA0A04FC94B}">
-              <ma14:wrappingTextBoxFlag xmlns="" xmlns:m="http://schemas.openxmlformats.org/officeDocument/2006/math" xmlns:a14="http://schemas.microsoft.com/office/drawing/2010/main" xmlns:ma14="http://schemas.microsoft.com/office/mac/drawingml/2011/main" val="1"/>
+              <ma14:wrappingTextBoxFlag xmlns:ma14="http://schemas.microsoft.com/office/mac/drawingml/2011/main" xmlns:a14="http://schemas.microsoft.com/office/drawing/2010/main" xmlns:m="http://schemas.openxmlformats.org/officeDocument/2006/math" xmlns="" val="1"/>
             </a:ext>
           </a:extLst>
         </p:spPr>
@@ -3013,7 +3879,7 @@
           </a:prstGeom>
           <a:extLst>
             <a:ext uri="{C572A759-6A51-4108-AA02-DFA0A04FC94B}">
-              <ma14:wrappingTextBoxFlag xmlns="" xmlns:m="http://schemas.openxmlformats.org/officeDocument/2006/math" xmlns:a14="http://schemas.microsoft.com/office/drawing/2010/main" xmlns:ma14="http://schemas.microsoft.com/office/mac/drawingml/2011/main" val="1"/>
+              <ma14:wrappingTextBoxFlag xmlns:ma14="http://schemas.microsoft.com/office/mac/drawingml/2011/main" xmlns:a14="http://schemas.microsoft.com/office/drawing/2010/main" xmlns:m="http://schemas.openxmlformats.org/officeDocument/2006/math" xmlns="" val="1"/>
             </a:ext>
           </a:extLst>
         </p:spPr>
@@ -3048,7 +3914,7 @@
           </a:ln>
           <a:extLst>
             <a:ext uri="{C572A759-6A51-4108-AA02-DFA0A04FC94B}">
-              <ma14:wrappingTextBoxFlag xmlns="" xmlns:m="http://schemas.openxmlformats.org/officeDocument/2006/math" xmlns:a14="http://schemas.microsoft.com/office/drawing/2010/main" xmlns:ma14="http://schemas.microsoft.com/office/mac/drawingml/2011/main" val="1"/>
+              <ma14:wrappingTextBoxFlag xmlns:ma14="http://schemas.microsoft.com/office/mac/drawingml/2011/main" xmlns:a14="http://schemas.microsoft.com/office/drawing/2010/main" xmlns:m="http://schemas.openxmlformats.org/officeDocument/2006/math" xmlns="" val="1"/>
             </a:ext>
           </a:extLst>
         </p:spPr>
@@ -3087,7 +3953,7 @@
           </a:ln>
           <a:extLst>
             <a:ext uri="{C572A759-6A51-4108-AA02-DFA0A04FC94B}">
-              <ma14:wrappingTextBoxFlag xmlns="" xmlns:m="http://schemas.openxmlformats.org/officeDocument/2006/math" xmlns:a14="http://schemas.microsoft.com/office/drawing/2010/main" xmlns:ma14="http://schemas.microsoft.com/office/mac/drawingml/2011/main" val="1"/>
+              <ma14:wrappingTextBoxFlag xmlns:ma14="http://schemas.microsoft.com/office/mac/drawingml/2011/main" xmlns:a14="http://schemas.microsoft.com/office/drawing/2010/main" xmlns:m="http://schemas.openxmlformats.org/officeDocument/2006/math" xmlns="" val="1"/>
             </a:ext>
           </a:extLst>
         </p:spPr>
@@ -3128,7 +3994,7 @@
           </a:ln>
           <a:extLst>
             <a:ext uri="{C572A759-6A51-4108-AA02-DFA0A04FC94B}">
-              <ma14:wrappingTextBoxFlag xmlns="" xmlns:m="http://schemas.openxmlformats.org/officeDocument/2006/math" xmlns:a14="http://schemas.microsoft.com/office/drawing/2010/main" xmlns:ma14="http://schemas.microsoft.com/office/mac/drawingml/2011/main" val="1"/>
+              <ma14:wrappingTextBoxFlag xmlns:ma14="http://schemas.microsoft.com/office/mac/drawingml/2011/main" xmlns:a14="http://schemas.microsoft.com/office/drawing/2010/main" xmlns:m="http://schemas.openxmlformats.org/officeDocument/2006/math" xmlns="" val="1"/>
             </a:ext>
           </a:extLst>
         </p:spPr>
@@ -3178,7 +4044,7 @@
           </a:ln>
           <a:extLst>
             <a:ext uri="{C572A759-6A51-4108-AA02-DFA0A04FC94B}">
-              <ma14:wrappingTextBoxFlag xmlns="" xmlns:m="http://schemas.openxmlformats.org/officeDocument/2006/math" xmlns:a14="http://schemas.microsoft.com/office/drawing/2010/main" xmlns:ma14="http://schemas.microsoft.com/office/mac/drawingml/2011/main" val="1"/>
+              <ma14:wrappingTextBoxFlag xmlns:ma14="http://schemas.microsoft.com/office/mac/drawingml/2011/main" xmlns:a14="http://schemas.microsoft.com/office/drawing/2010/main" xmlns:m="http://schemas.openxmlformats.org/officeDocument/2006/math" xmlns="" val="1"/>
             </a:ext>
           </a:extLst>
         </p:spPr>
@@ -3218,7 +4084,7 @@
           </a:ln>
           <a:extLst>
             <a:ext uri="{C572A759-6A51-4108-AA02-DFA0A04FC94B}">
-              <ma14:wrappingTextBoxFlag xmlns="" xmlns:m="http://schemas.openxmlformats.org/officeDocument/2006/math" xmlns:a14="http://schemas.microsoft.com/office/drawing/2010/main" xmlns:ma14="http://schemas.microsoft.com/office/mac/drawingml/2011/main" val="1"/>
+              <ma14:wrappingTextBoxFlag xmlns:ma14="http://schemas.microsoft.com/office/mac/drawingml/2011/main" xmlns:a14="http://schemas.microsoft.com/office/drawing/2010/main" xmlns:m="http://schemas.openxmlformats.org/officeDocument/2006/math" xmlns="" val="1"/>
             </a:ext>
           </a:extLst>
         </p:spPr>
@@ -3264,7 +4130,7 @@
           </a:ln>
           <a:extLst>
             <a:ext uri="{C572A759-6A51-4108-AA02-DFA0A04FC94B}">
-              <ma14:wrappingTextBoxFlag xmlns="" xmlns:m="http://schemas.openxmlformats.org/officeDocument/2006/math" xmlns:a14="http://schemas.microsoft.com/office/drawing/2010/main" xmlns:ma14="http://schemas.microsoft.com/office/mac/drawingml/2011/main" val="1"/>
+              <ma14:wrappingTextBoxFlag xmlns:ma14="http://schemas.microsoft.com/office/mac/drawingml/2011/main" xmlns:a14="http://schemas.microsoft.com/office/drawing/2010/main" xmlns:m="http://schemas.openxmlformats.org/officeDocument/2006/math" xmlns="" val="1"/>
             </a:ext>
           </a:extLst>
         </p:spPr>
@@ -3303,7 +4169,7 @@
           </a:ln>
           <a:extLst>
             <a:ext uri="{C572A759-6A51-4108-AA02-DFA0A04FC94B}">
-              <ma14:wrappingTextBoxFlag xmlns="" xmlns:m="http://schemas.openxmlformats.org/officeDocument/2006/math" xmlns:a14="http://schemas.microsoft.com/office/drawing/2010/main" xmlns:ma14="http://schemas.microsoft.com/office/mac/drawingml/2011/main" val="1"/>
+              <ma14:wrappingTextBoxFlag xmlns:ma14="http://schemas.microsoft.com/office/mac/drawingml/2011/main" xmlns:a14="http://schemas.microsoft.com/office/drawing/2010/main" xmlns:m="http://schemas.openxmlformats.org/officeDocument/2006/math" xmlns="" val="1"/>
             </a:ext>
           </a:extLst>
         </p:spPr>
@@ -3416,7 +4282,7 @@
           </a:ln>
           <a:extLst>
             <a:ext uri="{C572A759-6A51-4108-AA02-DFA0A04FC94B}">
-              <ma14:wrappingTextBoxFlag xmlns="" xmlns:m="http://schemas.openxmlformats.org/officeDocument/2006/math" xmlns:a14="http://schemas.microsoft.com/office/drawing/2010/main" xmlns:ma14="http://schemas.microsoft.com/office/mac/drawingml/2011/main" val="1"/>
+              <ma14:wrappingTextBoxFlag xmlns:ma14="http://schemas.microsoft.com/office/mac/drawingml/2011/main" xmlns:a14="http://schemas.microsoft.com/office/drawing/2010/main" xmlns:m="http://schemas.openxmlformats.org/officeDocument/2006/math" xmlns="" val="1"/>
             </a:ext>
           </a:extLst>
         </p:spPr>
@@ -3464,7 +4330,7 @@
           </a:prstGeom>
           <a:extLst>
             <a:ext uri="{C572A759-6A51-4108-AA02-DFA0A04FC94B}">
-              <ma14:wrappingTextBoxFlag xmlns="" xmlns:m="http://schemas.openxmlformats.org/officeDocument/2006/math" xmlns:a14="http://schemas.microsoft.com/office/drawing/2010/main" xmlns:ma14="http://schemas.microsoft.com/office/mac/drawingml/2011/main" val="1"/>
+              <ma14:wrappingTextBoxFlag xmlns:ma14="http://schemas.microsoft.com/office/mac/drawingml/2011/main" xmlns:a14="http://schemas.microsoft.com/office/drawing/2010/main" xmlns:m="http://schemas.openxmlformats.org/officeDocument/2006/math" xmlns="" val="1"/>
             </a:ext>
           </a:extLst>
         </p:spPr>
@@ -3499,7 +4365,7 @@
           </a:ln>
           <a:extLst>
             <a:ext uri="{C572A759-6A51-4108-AA02-DFA0A04FC94B}">
-              <ma14:wrappingTextBoxFlag xmlns="" xmlns:m="http://schemas.openxmlformats.org/officeDocument/2006/math" xmlns:a14="http://schemas.microsoft.com/office/drawing/2010/main" xmlns:ma14="http://schemas.microsoft.com/office/mac/drawingml/2011/main" val="1"/>
+              <ma14:wrappingTextBoxFlag xmlns:ma14="http://schemas.microsoft.com/office/mac/drawingml/2011/main" xmlns:a14="http://schemas.microsoft.com/office/drawing/2010/main" xmlns:m="http://schemas.openxmlformats.org/officeDocument/2006/math" xmlns="" val="1"/>
             </a:ext>
           </a:extLst>
         </p:spPr>
@@ -3578,7 +4444,7 @@
           </a:ln>
           <a:extLst>
             <a:ext uri="{C572A759-6A51-4108-AA02-DFA0A04FC94B}">
-              <ma14:wrappingTextBoxFlag xmlns="" xmlns:m="http://schemas.openxmlformats.org/officeDocument/2006/math" xmlns:a14="http://schemas.microsoft.com/office/drawing/2010/main" xmlns:ma14="http://schemas.microsoft.com/office/mac/drawingml/2011/main" val="1"/>
+              <ma14:wrappingTextBoxFlag xmlns:ma14="http://schemas.microsoft.com/office/mac/drawingml/2011/main" xmlns:a14="http://schemas.microsoft.com/office/drawing/2010/main" xmlns:m="http://schemas.openxmlformats.org/officeDocument/2006/math" xmlns="" val="1"/>
             </a:ext>
           </a:extLst>
         </p:spPr>
@@ -3617,7 +4483,7 @@
           </a:ln>
           <a:extLst>
             <a:ext uri="{C572A759-6A51-4108-AA02-DFA0A04FC94B}">
-              <ma14:wrappingTextBoxFlag xmlns="" xmlns:m="http://schemas.openxmlformats.org/officeDocument/2006/math" xmlns:a14="http://schemas.microsoft.com/office/drawing/2010/main" xmlns:ma14="http://schemas.microsoft.com/office/mac/drawingml/2011/main" val="1"/>
+              <ma14:wrappingTextBoxFlag xmlns:ma14="http://schemas.microsoft.com/office/mac/drawingml/2011/main" xmlns:a14="http://schemas.microsoft.com/office/drawing/2010/main" xmlns:m="http://schemas.openxmlformats.org/officeDocument/2006/math" xmlns="" val="1"/>
             </a:ext>
           </a:extLst>
         </p:spPr>
@@ -3675,7 +4541,7 @@
           </a:ln>
           <a:extLst>
             <a:ext uri="{C572A759-6A51-4108-AA02-DFA0A04FC94B}">
-              <ma14:wrappingTextBoxFlag xmlns="" xmlns:m="http://schemas.openxmlformats.org/officeDocument/2006/math" xmlns:a14="http://schemas.microsoft.com/office/drawing/2010/main" xmlns:ma14="http://schemas.microsoft.com/office/mac/drawingml/2011/main" val="1"/>
+              <ma14:wrappingTextBoxFlag xmlns:ma14="http://schemas.microsoft.com/office/mac/drawingml/2011/main" xmlns:a14="http://schemas.microsoft.com/office/drawing/2010/main" xmlns:m="http://schemas.openxmlformats.org/officeDocument/2006/math" xmlns="" val="1"/>
             </a:ext>
           </a:extLst>
         </p:spPr>
@@ -3734,7 +4600,7 @@
           </a:ln>
           <a:extLst>
             <a:ext uri="{C572A759-6A51-4108-AA02-DFA0A04FC94B}">
-              <ma14:wrappingTextBoxFlag xmlns="" xmlns:m="http://schemas.openxmlformats.org/officeDocument/2006/math" xmlns:a14="http://schemas.microsoft.com/office/drawing/2010/main" xmlns:ma14="http://schemas.microsoft.com/office/mac/drawingml/2011/main" val="1"/>
+              <ma14:wrappingTextBoxFlag xmlns:ma14="http://schemas.microsoft.com/office/mac/drawingml/2011/main" xmlns:a14="http://schemas.microsoft.com/office/drawing/2010/main" xmlns:m="http://schemas.openxmlformats.org/officeDocument/2006/math" xmlns="" val="1"/>
             </a:ext>
           </a:extLst>
         </p:spPr>
@@ -3793,7 +4659,7 @@
           </a:ln>
           <a:extLst>
             <a:ext uri="{C572A759-6A51-4108-AA02-DFA0A04FC94B}">
-              <ma14:wrappingTextBoxFlag xmlns="" xmlns:m="http://schemas.openxmlformats.org/officeDocument/2006/math" xmlns:a14="http://schemas.microsoft.com/office/drawing/2010/main" xmlns:ma14="http://schemas.microsoft.com/office/mac/drawingml/2011/main" val="1"/>
+              <ma14:wrappingTextBoxFlag xmlns:ma14="http://schemas.microsoft.com/office/mac/drawingml/2011/main" xmlns:a14="http://schemas.microsoft.com/office/drawing/2010/main" xmlns:m="http://schemas.openxmlformats.org/officeDocument/2006/math" xmlns="" val="1"/>
             </a:ext>
           </a:extLst>
         </p:spPr>
@@ -3867,7 +4733,7 @@
           </a:ln>
           <a:extLst>
             <a:ext uri="{C572A759-6A51-4108-AA02-DFA0A04FC94B}">
-              <ma14:wrappingTextBoxFlag xmlns="" xmlns:m="http://schemas.openxmlformats.org/officeDocument/2006/math" xmlns:a14="http://schemas.microsoft.com/office/drawing/2010/main" xmlns:ma14="http://schemas.microsoft.com/office/mac/drawingml/2011/main" val="1"/>
+              <ma14:wrappingTextBoxFlag xmlns:ma14="http://schemas.microsoft.com/office/mac/drawingml/2011/main" xmlns:a14="http://schemas.microsoft.com/office/drawing/2010/main" xmlns:m="http://schemas.openxmlformats.org/officeDocument/2006/math" xmlns="" val="1"/>
             </a:ext>
           </a:extLst>
         </p:spPr>
@@ -3915,7 +4781,7 @@
           </a:prstGeom>
           <a:extLst>
             <a:ext uri="{C572A759-6A51-4108-AA02-DFA0A04FC94B}">
-              <ma14:wrappingTextBoxFlag xmlns="" xmlns:m="http://schemas.openxmlformats.org/officeDocument/2006/math" xmlns:a14="http://schemas.microsoft.com/office/drawing/2010/main" xmlns:ma14="http://schemas.microsoft.com/office/mac/drawingml/2011/main" val="1"/>
+              <ma14:wrappingTextBoxFlag xmlns:ma14="http://schemas.microsoft.com/office/mac/drawingml/2011/main" xmlns:a14="http://schemas.microsoft.com/office/drawing/2010/main" xmlns:m="http://schemas.openxmlformats.org/officeDocument/2006/math" xmlns="" val="1"/>
             </a:ext>
           </a:extLst>
         </p:spPr>
@@ -3950,7 +4816,7 @@
           </a:ln>
           <a:extLst>
             <a:ext uri="{C572A759-6A51-4108-AA02-DFA0A04FC94B}">
-              <ma14:wrappingTextBoxFlag xmlns="" xmlns:m="http://schemas.openxmlformats.org/officeDocument/2006/math" xmlns:a14="http://schemas.microsoft.com/office/drawing/2010/main" xmlns:ma14="http://schemas.microsoft.com/office/mac/drawingml/2011/main" val="1"/>
+              <ma14:wrappingTextBoxFlag xmlns:ma14="http://schemas.microsoft.com/office/mac/drawingml/2011/main" xmlns:a14="http://schemas.microsoft.com/office/drawing/2010/main" xmlns:m="http://schemas.openxmlformats.org/officeDocument/2006/math" xmlns="" val="1"/>
             </a:ext>
           </a:extLst>
         </p:spPr>
@@ -4021,7 +4887,7 @@
           </a:ln>
           <a:extLst>
             <a:ext uri="{C572A759-6A51-4108-AA02-DFA0A04FC94B}">
-              <ma14:wrappingTextBoxFlag xmlns="" xmlns:m="http://schemas.openxmlformats.org/officeDocument/2006/math" xmlns:a14="http://schemas.microsoft.com/office/drawing/2010/main" xmlns:ma14="http://schemas.microsoft.com/office/mac/drawingml/2011/main" val="1"/>
+              <ma14:wrappingTextBoxFlag xmlns:ma14="http://schemas.microsoft.com/office/mac/drawingml/2011/main" xmlns:a14="http://schemas.microsoft.com/office/drawing/2010/main" xmlns:m="http://schemas.openxmlformats.org/officeDocument/2006/math" xmlns="" val="1"/>
             </a:ext>
           </a:extLst>
         </p:spPr>
@@ -4061,7 +4927,7 @@
           </a:ln>
           <a:extLst>
             <a:ext uri="{C572A759-6A51-4108-AA02-DFA0A04FC94B}">
-              <ma14:wrappingTextBoxFlag xmlns="" xmlns:m="http://schemas.openxmlformats.org/officeDocument/2006/math" xmlns:a14="http://schemas.microsoft.com/office/drawing/2010/main" xmlns:ma14="http://schemas.microsoft.com/office/mac/drawingml/2011/main" val="1"/>
+              <ma14:wrappingTextBoxFlag xmlns:ma14="http://schemas.microsoft.com/office/mac/drawingml/2011/main" xmlns:a14="http://schemas.microsoft.com/office/drawing/2010/main" xmlns:m="http://schemas.openxmlformats.org/officeDocument/2006/math" xmlns="" val="1"/>
             </a:ext>
           </a:extLst>
         </p:spPr>
@@ -4464,7 +5330,7 @@
           </a:ln>
           <a:extLst>
             <a:ext uri="{C572A759-6A51-4108-AA02-DFA0A04FC94B}">
-              <ma14:wrappingTextBoxFlag xmlns="" xmlns:m="http://schemas.openxmlformats.org/officeDocument/2006/math" xmlns:a14="http://schemas.microsoft.com/office/drawing/2010/main" xmlns:ma14="http://schemas.microsoft.com/office/mac/drawingml/2011/main" val="1"/>
+              <ma14:wrappingTextBoxFlag xmlns:ma14="http://schemas.microsoft.com/office/mac/drawingml/2011/main" xmlns:a14="http://schemas.microsoft.com/office/drawing/2010/main" xmlns:m="http://schemas.openxmlformats.org/officeDocument/2006/math" xmlns="" val="1"/>
             </a:ext>
           </a:extLst>
         </p:spPr>
@@ -4512,7 +5378,7 @@
           </a:prstGeom>
           <a:extLst>
             <a:ext uri="{C572A759-6A51-4108-AA02-DFA0A04FC94B}">
-              <ma14:wrappingTextBoxFlag xmlns="" xmlns:m="http://schemas.openxmlformats.org/officeDocument/2006/math" xmlns:a14="http://schemas.microsoft.com/office/drawing/2010/main" xmlns:ma14="http://schemas.microsoft.com/office/mac/drawingml/2011/main" val="1"/>
+              <ma14:wrappingTextBoxFlag xmlns:ma14="http://schemas.microsoft.com/office/mac/drawingml/2011/main" xmlns:a14="http://schemas.microsoft.com/office/drawing/2010/main" xmlns:m="http://schemas.openxmlformats.org/officeDocument/2006/math" xmlns="" val="1"/>
             </a:ext>
           </a:extLst>
         </p:spPr>
@@ -4547,7 +5413,7 @@
           </a:ln>
           <a:extLst>
             <a:ext uri="{C572A759-6A51-4108-AA02-DFA0A04FC94B}">
-              <ma14:wrappingTextBoxFlag xmlns="" xmlns:m="http://schemas.openxmlformats.org/officeDocument/2006/math" xmlns:a14="http://schemas.microsoft.com/office/drawing/2010/main" xmlns:ma14="http://schemas.microsoft.com/office/mac/drawingml/2011/main" val="1"/>
+              <ma14:wrappingTextBoxFlag xmlns:ma14="http://schemas.microsoft.com/office/mac/drawingml/2011/main" xmlns:a14="http://schemas.microsoft.com/office/drawing/2010/main" xmlns:m="http://schemas.openxmlformats.org/officeDocument/2006/math" xmlns="" val="1"/>
             </a:ext>
           </a:extLst>
         </p:spPr>
@@ -4586,7 +5452,7 @@
           </a:ln>
           <a:extLst>
             <a:ext uri="{C572A759-6A51-4108-AA02-DFA0A04FC94B}">
-              <ma14:wrappingTextBoxFlag xmlns="" xmlns:m="http://schemas.openxmlformats.org/officeDocument/2006/math" xmlns:a14="http://schemas.microsoft.com/office/drawing/2010/main" xmlns:ma14="http://schemas.microsoft.com/office/mac/drawingml/2011/main" val="1"/>
+              <ma14:wrappingTextBoxFlag xmlns:ma14="http://schemas.microsoft.com/office/mac/drawingml/2011/main" xmlns:a14="http://schemas.microsoft.com/office/drawing/2010/main" xmlns:m="http://schemas.openxmlformats.org/officeDocument/2006/math" xmlns="" val="1"/>
             </a:ext>
           </a:extLst>
         </p:spPr>
@@ -5095,534 +5961,200 @@
       </p:grpSpPr>
       <p:sp>
         <p:nvSpPr>
-          <p:cNvPr id="71" name="Google Shape;46;p1"/>
-          <p:cNvSpPr txBox="1"/>
-          <p:nvPr/>
+          <p:cNvPr id="2" name="Title 1">
+            <a:extLst>
+              <a:ext uri="{FF2B5EF4-FFF2-40B4-BE49-F238E27FC236}">
+                <a16:creationId xmlns:a16="http://schemas.microsoft.com/office/drawing/2014/main" id="{3D7661CD-E5CB-39B1-0F36-47764FC6C8B1}"/>
+              </a:ext>
+            </a:extLst>
+          </p:cNvPr>
+          <p:cNvSpPr>
+            <a:spLocks noGrp="1"/>
+          </p:cNvSpPr>
+          <p:nvPr>
+            <p:ph type="title"/>
+          </p:nvPr>
+        </p:nvSpPr>
+        <p:spPr/>
+        <p:txBody>
+          <a:bodyPr>
+            <a:normAutofit/>
+          </a:bodyPr>
+          <a:lstStyle/>
+          <a:p>
+            <a:pPr marL="114300"/>
+            <a:r>
+              <a:rPr lang="en-IN" sz="3600" b="1" dirty="0"/>
+              <a:t>Homepage UI</a:t>
+            </a:r>
+          </a:p>
+        </p:txBody>
+      </p:sp>
+      <p:sp>
+        <p:nvSpPr>
+          <p:cNvPr id="3" name="Text Placeholder 2">
+            <a:extLst>
+              <a:ext uri="{FF2B5EF4-FFF2-40B4-BE49-F238E27FC236}">
+                <a16:creationId xmlns:a16="http://schemas.microsoft.com/office/drawing/2014/main" id="{976FDE28-AB70-B9A8-2195-C3BB72592031}"/>
+              </a:ext>
+            </a:extLst>
+          </p:cNvPr>
+          <p:cNvSpPr>
+            <a:spLocks noGrp="1"/>
+          </p:cNvSpPr>
+          <p:nvPr>
+            <p:ph type="body" idx="1"/>
+          </p:nvPr>
         </p:nvSpPr>
         <p:spPr>
           <a:xfrm>
-            <a:off x="502925" y="6414780"/>
-            <a:ext cx="2042150" cy="248265"/>
+            <a:off x="137160" y="1005840"/>
+            <a:ext cx="8787384" cy="5486400"/>
+          </a:xfrm>
+        </p:spPr>
+        <p:txBody>
+          <a:bodyPr/>
+          <a:lstStyle/>
+          <a:p>
+            <a:endParaRPr lang="en-US" dirty="0"/>
+          </a:p>
+          <a:p>
+            <a:endParaRPr lang="en-IN" dirty="0"/>
+          </a:p>
+          <a:p>
+            <a:endParaRPr lang="en-IN" dirty="0"/>
+          </a:p>
+          <a:p>
+            <a:endParaRPr lang="en-IN" dirty="0"/>
+          </a:p>
+          <a:p>
+            <a:endParaRPr lang="en-IN" dirty="0"/>
+          </a:p>
+          <a:p>
+            <a:endParaRPr lang="en-IN" dirty="0"/>
+          </a:p>
+          <a:p>
+            <a:endParaRPr lang="en-IN" dirty="0"/>
+          </a:p>
+          <a:p>
+            <a:endParaRPr lang="en-IN" dirty="0"/>
+          </a:p>
+        </p:txBody>
+      </p:sp>
+      <p:pic>
+        <p:nvPicPr>
+          <p:cNvPr id="5" name="Picture 4">
+            <a:extLst>
+              <a:ext uri="{FF2B5EF4-FFF2-40B4-BE49-F238E27FC236}">
+                <a16:creationId xmlns:a16="http://schemas.microsoft.com/office/drawing/2014/main" id="{DFC7D073-1F56-C473-71E5-A2147B643260}"/>
+              </a:ext>
+            </a:extLst>
+          </p:cNvPr>
+          <p:cNvPicPr>
+            <a:picLocks noChangeAspect="1"/>
+          </p:cNvPicPr>
+          <p:nvPr/>
+        </p:nvPicPr>
+        <p:blipFill>
+          <a:blip r:embed="rId2" cstate="print">
+            <a:extLst>
+              <a:ext uri="{28A0092B-C50C-407E-A947-70E740481C1C}">
+                <a14:useLocalDpi xmlns:a14="http://schemas.microsoft.com/office/drawing/2010/main" val="0"/>
+              </a:ext>
+            </a:extLst>
+          </a:blip>
+          <a:stretch>
+            <a:fillRect/>
+          </a:stretch>
+        </p:blipFill>
+        <p:spPr>
+          <a:xfrm>
+            <a:off x="1263806" y="838200"/>
+            <a:ext cx="5968279" cy="2510960"/>
           </a:xfrm>
           <a:prstGeom prst="rect">
             <a:avLst/>
           </a:prstGeom>
-          <a:ln w="12700">
-            <a:miter lim="400000"/>
-          </a:ln>
-          <a:extLst>
-            <a:ext uri="{C572A759-6A51-4108-AA02-DFA0A04FC94B}">
-              <ma14:wrappingTextBoxFlag xmlns="" xmlns:m="http://schemas.openxmlformats.org/officeDocument/2006/math" xmlns:a14="http://schemas.microsoft.com/office/drawing/2010/main" xmlns:ma14="http://schemas.microsoft.com/office/mac/drawingml/2011/main" val="1"/>
-            </a:ext>
-          </a:extLst>
         </p:spPr>
-        <p:txBody>
-          <a:bodyPr lIns="45699" tIns="45699" rIns="45699" bIns="45699" anchor="ctr">
-            <a:spAutoFit/>
-          </a:bodyPr>
-          <a:lstStyle>
-            <a:lvl1pPr>
-              <a:defRPr sz="1200">
-                <a:solidFill>
-                  <a:srgbClr val="898989"/>
-                </a:solidFill>
-                <a:latin typeface="Calibri"/>
-                <a:ea typeface="Calibri"/>
-                <a:cs typeface="Calibri"/>
-                <a:sym typeface="Calibri"/>
-              </a:defRPr>
-            </a:lvl1pPr>
-          </a:lstStyle>
-          <a:p>
-            <a:r>
-              <a:t>22CS026</a:t>
-            </a:r>
-          </a:p>
-        </p:txBody>
-      </p:sp>
-      <p:sp>
-        <p:nvSpPr>
-          <p:cNvPr id="72" name="Google Shape;47;p1"/>
-          <p:cNvSpPr txBox="1">
-            <a:spLocks noGrp="1"/>
-          </p:cNvSpPr>
-          <p:nvPr>
-            <p:ph type="sldNum" sz="quarter" idx="2"/>
-          </p:nvPr>
-        </p:nvSpPr>
+      </p:pic>
+      <p:pic>
+        <p:nvPicPr>
+          <p:cNvPr id="11" name="Picture 10">
+            <a:extLst>
+              <a:ext uri="{FF2B5EF4-FFF2-40B4-BE49-F238E27FC236}">
+                <a16:creationId xmlns:a16="http://schemas.microsoft.com/office/drawing/2014/main" id="{66066BC7-49DD-8A4F-7C1E-180706DD3945}"/>
+              </a:ext>
+            </a:extLst>
+          </p:cNvPr>
+          <p:cNvPicPr>
+            <a:picLocks noChangeAspect="1"/>
+          </p:cNvPicPr>
+          <p:nvPr/>
+        </p:nvPicPr>
+        <p:blipFill>
+          <a:blip r:embed="rId3" cstate="print">
+            <a:extLst>
+              <a:ext uri="{28A0092B-C50C-407E-A947-70E740481C1C}">
+                <a14:useLocalDpi xmlns:a14="http://schemas.microsoft.com/office/drawing/2010/main" val="0"/>
+              </a:ext>
+            </a:extLst>
+          </a:blip>
+          <a:stretch>
+            <a:fillRect/>
+          </a:stretch>
+        </p:blipFill>
         <p:spPr>
           <a:xfrm>
-            <a:off x="8505458" y="6414780"/>
-            <a:ext cx="181343" cy="248265"/>
+            <a:off x="572058" y="3349160"/>
+            <a:ext cx="6912864" cy="2423456"/>
           </a:xfrm>
           <a:prstGeom prst="rect">
             <a:avLst/>
           </a:prstGeom>
-          <a:extLst>
-            <a:ext uri="{C572A759-6A51-4108-AA02-DFA0A04FC94B}">
-              <ma14:wrappingTextBoxFlag xmlns="" xmlns:m="http://schemas.openxmlformats.org/officeDocument/2006/math" xmlns:a14="http://schemas.microsoft.com/office/drawing/2010/main" xmlns:ma14="http://schemas.microsoft.com/office/mac/drawingml/2011/main" val="1"/>
-            </a:ext>
-          </a:extLst>
         </p:spPr>
-        <p:txBody>
-          <a:bodyPr/>
-          <a:lstStyle/>
-          <a:p>
-            <a:fld id="{86CB4B4D-7CA3-9044-876B-883B54F8677D}" type="slidenum">
-              <a:rPr/>
-              <a:t>7</a:t>
-            </a:fld>
-            <a:endParaRPr/>
-          </a:p>
-        </p:txBody>
-      </p:sp>
-      <p:sp>
-        <p:nvSpPr>
-          <p:cNvPr id="73" name="Google Shape;48;p1"/>
-          <p:cNvSpPr txBox="1"/>
+      </p:pic>
+      <p:pic>
+        <p:nvPicPr>
+          <p:cNvPr id="15" name="Picture 14">
+            <a:extLst>
+              <a:ext uri="{FF2B5EF4-FFF2-40B4-BE49-F238E27FC236}">
+                <a16:creationId xmlns:a16="http://schemas.microsoft.com/office/drawing/2014/main" id="{B304BE08-6B30-E431-7346-9122E012FEB3}"/>
+              </a:ext>
+            </a:extLst>
+          </p:cNvPr>
+          <p:cNvPicPr>
+            <a:picLocks noChangeAspect="1"/>
+          </p:cNvPicPr>
           <p:nvPr/>
-        </p:nvSpPr>
+        </p:nvPicPr>
+        <p:blipFill>
+          <a:blip r:embed="rId4" cstate="print">
+            <a:extLst>
+              <a:ext uri="{28A0092B-C50C-407E-A947-70E740481C1C}">
+                <a14:useLocalDpi xmlns:a14="http://schemas.microsoft.com/office/drawing/2010/main" val="0"/>
+              </a:ext>
+            </a:extLst>
+          </a:blip>
+          <a:stretch>
+            <a:fillRect/>
+          </a:stretch>
+        </p:blipFill>
         <p:spPr>
           <a:xfrm>
-            <a:off x="58325" y="2338162"/>
-            <a:ext cx="9027350" cy="2872306"/>
+            <a:off x="1143000" y="5791200"/>
+            <a:ext cx="6341922" cy="868680"/>
           </a:xfrm>
           <a:prstGeom prst="rect">
             <a:avLst/>
           </a:prstGeom>
-          <a:ln w="12700">
-            <a:miter lim="400000"/>
-          </a:ln>
-          <a:extLst>
-            <a:ext uri="{C572A759-6A51-4108-AA02-DFA0A04FC94B}">
-              <ma14:wrappingTextBoxFlag xmlns="" xmlns:m="http://schemas.openxmlformats.org/officeDocument/2006/math" xmlns:a14="http://schemas.microsoft.com/office/drawing/2010/main" xmlns:ma14="http://schemas.microsoft.com/office/mac/drawingml/2011/main" val="1"/>
-            </a:ext>
-          </a:extLst>
         </p:spPr>
-        <p:txBody>
-          <a:bodyPr lIns="33099" tIns="33099" rIns="33099" bIns="33099" anchor="ctr">
-            <a:spAutoFit/>
-          </a:bodyPr>
-          <a:lstStyle/>
-          <a:p>
-            <a:pPr algn="ctr">
-              <a:defRPr sz="3200" b="1">
-                <a:solidFill>
-                  <a:srgbClr val="FF0000"/>
-                </a:solidFill>
-              </a:defRPr>
-            </a:pPr>
-            <a:endParaRPr/>
-          </a:p>
-          <a:p>
-            <a:pPr algn="ctr">
-              <a:defRPr sz="3200" b="1">
-                <a:solidFill>
-                  <a:srgbClr val="FF0000"/>
-                </a:solidFill>
-              </a:defRPr>
-            </a:pPr>
-            <a:endParaRPr/>
-          </a:p>
-          <a:p>
-            <a:pPr algn="ctr">
-              <a:defRPr sz="3200" b="1">
-                <a:solidFill>
-                  <a:srgbClr val="FF0000"/>
-                </a:solidFill>
-              </a:defRPr>
-            </a:pPr>
-            <a:endParaRPr/>
-          </a:p>
-          <a:p>
-            <a:pPr algn="ctr">
-              <a:defRPr sz="3200" b="1">
-                <a:solidFill>
-                  <a:srgbClr val="FF0000"/>
-                </a:solidFill>
-              </a:defRPr>
-            </a:pPr>
-            <a:br/>
-            <a:endParaRPr/>
-          </a:p>
-        </p:txBody>
-      </p:sp>
-      <p:sp>
-        <p:nvSpPr>
-          <p:cNvPr id="74" name="TextBox 1"/>
-          <p:cNvSpPr txBox="1"/>
-          <p:nvPr/>
-        </p:nvSpPr>
-        <p:spPr>
-          <a:xfrm>
-            <a:off x="2814359" y="1051421"/>
-            <a:ext cx="3660761" cy="510777"/>
-          </a:xfrm>
-          <a:prstGeom prst="rect">
-            <a:avLst/>
-          </a:prstGeom>
-          <a:ln w="12700">
-            <a:miter lim="400000"/>
-          </a:ln>
-          <a:extLst>
-            <a:ext uri="{C572A759-6A51-4108-AA02-DFA0A04FC94B}">
-              <ma14:wrappingTextBoxFlag xmlns="" xmlns:m="http://schemas.openxmlformats.org/officeDocument/2006/math" xmlns:a14="http://schemas.microsoft.com/office/drawing/2010/main" xmlns:ma14="http://schemas.microsoft.com/office/mac/drawingml/2011/main" val="1"/>
-            </a:ext>
-          </a:extLst>
-        </p:spPr>
-        <p:txBody>
-          <a:bodyPr wrap="none" lIns="45719" rIns="45719">
-            <a:spAutoFit/>
-          </a:bodyPr>
-          <a:lstStyle>
-            <a:lvl1pPr>
-              <a:defRPr sz="3000" b="1"/>
-            </a:lvl1pPr>
-          </a:lstStyle>
-          <a:p>
-            <a:r>
-              <a:t>Upcoming Features</a:t>
-            </a:r>
-          </a:p>
-        </p:txBody>
-      </p:sp>
-      <p:sp>
-        <p:nvSpPr>
-          <p:cNvPr id="75" name="Rectangle 1"/>
-          <p:cNvSpPr txBox="1"/>
-          <p:nvPr/>
-        </p:nvSpPr>
-        <p:spPr>
-          <a:xfrm>
-            <a:off x="534323" y="2971532"/>
-            <a:ext cx="7585148" cy="276999"/>
-          </a:xfrm>
-          <a:prstGeom prst="rect">
-            <a:avLst/>
-          </a:prstGeom>
-          <a:ln w="12700">
-            <a:miter lim="400000"/>
-          </a:ln>
-          <a:extLst>
-            <a:ext uri="{C572A759-6A51-4108-AA02-DFA0A04FC94B}">
-              <ma14:wrappingTextBoxFlag xmlns="" xmlns:m="http://schemas.openxmlformats.org/officeDocument/2006/math" xmlns:a14="http://schemas.microsoft.com/office/drawing/2010/main" xmlns:ma14="http://schemas.microsoft.com/office/mac/drawingml/2011/main" val="1"/>
-            </a:ext>
-          </a:extLst>
-        </p:spPr>
-        <p:txBody>
-          <a:bodyPr lIns="45719" rIns="45719" anchor="ctr">
-            <a:spAutoFit/>
-          </a:bodyPr>
-          <a:lstStyle/>
-          <a:p>
-            <a:pPr defTabSz="457200">
-              <a:spcBef>
-                <a:spcPts val="1200"/>
-              </a:spcBef>
-              <a:defRPr sz="1200">
-                <a:latin typeface="Times Roman"/>
-                <a:ea typeface="Times Roman"/>
-                <a:cs typeface="Times Roman"/>
-                <a:sym typeface="Times Roman"/>
-              </a:defRPr>
-            </a:pPr>
-            <a:endParaRPr dirty="0"/>
-          </a:p>
-        </p:txBody>
-      </p:sp>
-      <p:sp>
-        <p:nvSpPr>
-          <p:cNvPr id="2" name="Rectangle 1">
-            <a:extLst>
-              <a:ext uri="{FF2B5EF4-FFF2-40B4-BE49-F238E27FC236}">
-                <a16:creationId xmlns:a16="http://schemas.microsoft.com/office/drawing/2014/main" id="{715BB1B9-DEE5-2D69-1FC8-F37E11895D5F}"/>
-              </a:ext>
-            </a:extLst>
-          </p:cNvPr>
-          <p:cNvSpPr>
-            <a:spLocks noChangeArrowheads="1"/>
-          </p:cNvSpPr>
-          <p:nvPr/>
-        </p:nvSpPr>
-        <p:spPr bwMode="auto">
-          <a:xfrm>
-            <a:off x="402335" y="2274839"/>
-            <a:ext cx="7717135" cy="2308324"/>
-          </a:xfrm>
-          <a:prstGeom prst="rect">
-            <a:avLst/>
-          </a:prstGeom>
-          <a:noFill/>
-          <a:ln>
-            <a:noFill/>
-          </a:ln>
-          <a:effectLst/>
-          <a:extLst>
-            <a:ext uri="{909E8E84-426E-40DD-AFC4-6F175D3DCCD1}">
-              <a14:hiddenFill xmlns:a14="http://schemas.microsoft.com/office/drawing/2010/main">
-                <a:solidFill>
-                  <a:schemeClr val="accent1"/>
-                </a:solidFill>
-              </a14:hiddenFill>
-            </a:ext>
-            <a:ext uri="{91240B29-F687-4F45-9708-019B960494DF}">
-              <a14:hiddenLine xmlns:a14="http://schemas.microsoft.com/office/drawing/2010/main" w="9525">
-                <a:solidFill>
-                  <a:schemeClr val="tx1"/>
-                </a:solidFill>
-                <a:miter lim="800000"/>
-                <a:headEnd/>
-                <a:tailEnd/>
-              </a14:hiddenLine>
-            </a:ext>
-            <a:ext uri="{AF507438-7753-43E0-B8FC-AC1667EBCBE1}">
-              <a14:hiddenEffects xmlns:a14="http://schemas.microsoft.com/office/drawing/2010/main">
-                <a:effectLst>
-                  <a:outerShdw dist="35921" dir="2700000" algn="ctr" rotWithShape="0">
-                    <a:schemeClr val="bg2"/>
-                  </a:outerShdw>
-                </a:effectLst>
-              </a14:hiddenEffects>
-            </a:ext>
-          </a:extLst>
-        </p:spPr>
-        <p:txBody>
-          <a:bodyPr vert="horz" wrap="square" lIns="91440" tIns="45720" rIns="91440" bIns="45720" numCol="1" anchor="ctr" anchorCtr="0" compatLnSpc="1">
-            <a:prstTxWarp prst="textNoShape">
-              <a:avLst/>
-            </a:prstTxWarp>
-            <a:spAutoFit/>
-          </a:bodyPr>
-          <a:lstStyle/>
-          <a:p>
-            <a:pPr marL="0" marR="0" lvl="0" indent="0" algn="l" defTabSz="914400" rtl="0" eaLnBrk="0" fontAlgn="base" latinLnBrk="0" hangingPunct="0">
-              <a:lnSpc>
-                <a:spcPct val="100000"/>
-              </a:lnSpc>
-              <a:spcBef>
-                <a:spcPct val="0"/>
-              </a:spcBef>
-              <a:spcAft>
-                <a:spcPct val="0"/>
-              </a:spcAft>
-              <a:buClrTx/>
-              <a:buSzTx/>
-              <a:buFontTx/>
-              <a:buChar char="•"/>
-              <a:tabLst/>
-            </a:pPr>
-            <a:r>
-              <a:rPr kumimoji="0" lang="en-US" altLang="en-US" sz="1800" b="1" i="0" u="none" strike="noStrike" cap="none" normalizeH="0" baseline="0" dirty="0">
-                <a:ln>
-                  <a:noFill/>
-                </a:ln>
-                <a:solidFill>
-                  <a:schemeClr val="tx1"/>
-                </a:solidFill>
-                <a:effectLst/>
-                <a:latin typeface="Arial" panose="020B0604020202020204" pitchFamily="34" charset="0"/>
-              </a:rPr>
-              <a:t>Payment Gateway Integration</a:t>
-            </a:r>
-            <a:br>
-              <a:rPr kumimoji="0" lang="en-US" altLang="en-US" sz="1800" b="0" i="0" u="none" strike="noStrike" cap="none" normalizeH="0" baseline="0" dirty="0">
-                <a:ln>
-                  <a:noFill/>
-                </a:ln>
-                <a:solidFill>
-                  <a:schemeClr val="tx1"/>
-                </a:solidFill>
-                <a:effectLst/>
-                <a:latin typeface="Arial" panose="020B0604020202020204" pitchFamily="34" charset="0"/>
-              </a:rPr>
-            </a:br>
-            <a:r>
-              <a:rPr kumimoji="0" lang="en-US" altLang="en-US" sz="1800" b="0" i="0" u="none" strike="noStrike" cap="none" normalizeH="0" baseline="0" dirty="0">
-                <a:ln>
-                  <a:noFill/>
-                </a:ln>
-                <a:solidFill>
-                  <a:schemeClr val="tx1"/>
-                </a:solidFill>
-                <a:effectLst/>
-                <a:latin typeface="Arial" panose="020B0604020202020204" pitchFamily="34" charset="0"/>
-              </a:rPr>
-              <a:t>Integration with UPI for online payments</a:t>
-            </a:r>
-          </a:p>
-          <a:p>
-            <a:pPr marL="0" marR="0" lvl="0" indent="0" algn="l" defTabSz="914400" rtl="0" eaLnBrk="0" fontAlgn="base" latinLnBrk="0" hangingPunct="0">
-              <a:lnSpc>
-                <a:spcPct val="100000"/>
-              </a:lnSpc>
-              <a:spcBef>
-                <a:spcPct val="0"/>
-              </a:spcBef>
-              <a:spcAft>
-                <a:spcPct val="0"/>
-              </a:spcAft>
-              <a:buClrTx/>
-              <a:buSzTx/>
-              <a:tabLst/>
-            </a:pPr>
-            <a:r>
-              <a:rPr kumimoji="0" lang="en-US" altLang="en-US" sz="1800" b="0" i="0" u="none" strike="noStrike" cap="none" normalizeH="0" baseline="0" dirty="0">
-                <a:ln>
-                  <a:noFill/>
-                </a:ln>
-                <a:solidFill>
-                  <a:schemeClr val="tx1"/>
-                </a:solidFill>
-                <a:effectLst/>
-                <a:latin typeface="Arial" panose="020B0604020202020204" pitchFamily="34" charset="0"/>
-              </a:rPr>
-              <a:t> </a:t>
-            </a:r>
-          </a:p>
-          <a:p>
-            <a:pPr marL="0" marR="0" lvl="0" indent="0" algn="l" defTabSz="914400" rtl="0" eaLnBrk="0" fontAlgn="base" latinLnBrk="0" hangingPunct="0">
-              <a:lnSpc>
-                <a:spcPct val="100000"/>
-              </a:lnSpc>
-              <a:spcBef>
-                <a:spcPct val="0"/>
-              </a:spcBef>
-              <a:spcAft>
-                <a:spcPct val="0"/>
-              </a:spcAft>
-              <a:buClrTx/>
-              <a:buSzTx/>
-              <a:buFontTx/>
-              <a:buChar char="•"/>
-              <a:tabLst/>
-            </a:pPr>
-            <a:r>
-              <a:rPr kumimoji="0" lang="en-US" altLang="en-US" sz="1800" b="1" i="0" u="none" strike="noStrike" cap="none" normalizeH="0" baseline="0" dirty="0">
-                <a:ln>
-                  <a:noFill/>
-                </a:ln>
-                <a:solidFill>
-                  <a:schemeClr val="tx1"/>
-                </a:solidFill>
-                <a:effectLst/>
-                <a:latin typeface="Arial" panose="020B0604020202020204" pitchFamily="34" charset="0"/>
-              </a:rPr>
-              <a:t>User Authentication System</a:t>
-            </a:r>
-            <a:br>
-              <a:rPr kumimoji="0" lang="en-US" altLang="en-US" sz="1800" b="0" i="0" u="none" strike="noStrike" cap="none" normalizeH="0" baseline="0" dirty="0">
-                <a:ln>
-                  <a:noFill/>
-                </a:ln>
-                <a:solidFill>
-                  <a:schemeClr val="tx1"/>
-                </a:solidFill>
-                <a:effectLst/>
-                <a:latin typeface="Arial" panose="020B0604020202020204" pitchFamily="34" charset="0"/>
-              </a:rPr>
-            </a:br>
-            <a:r>
-              <a:rPr kumimoji="0" lang="en-US" altLang="en-US" sz="1800" b="0" i="0" u="none" strike="noStrike" cap="none" normalizeH="0" baseline="0" dirty="0">
-                <a:ln>
-                  <a:noFill/>
-                </a:ln>
-                <a:solidFill>
-                  <a:schemeClr val="tx1"/>
-                </a:solidFill>
-                <a:effectLst/>
-                <a:latin typeface="Arial" panose="020B0604020202020204" pitchFamily="34" charset="0"/>
-              </a:rPr>
-              <a:t>Login, signup, and user-specific cart</a:t>
-            </a:r>
-          </a:p>
-          <a:p>
-            <a:pPr marL="0" marR="0" lvl="0" indent="0" algn="l" defTabSz="914400" rtl="0" eaLnBrk="0" fontAlgn="base" latinLnBrk="0" hangingPunct="0">
-              <a:lnSpc>
-                <a:spcPct val="100000"/>
-              </a:lnSpc>
-              <a:spcBef>
-                <a:spcPct val="0"/>
-              </a:spcBef>
-              <a:spcAft>
-                <a:spcPct val="0"/>
-              </a:spcAft>
-              <a:buClrTx/>
-              <a:buSzTx/>
-              <a:tabLst/>
-            </a:pPr>
-            <a:r>
-              <a:rPr kumimoji="0" lang="en-US" altLang="en-US" sz="1800" b="0" i="0" u="none" strike="noStrike" cap="none" normalizeH="0" baseline="0" dirty="0">
-                <a:ln>
-                  <a:noFill/>
-                </a:ln>
-                <a:solidFill>
-                  <a:schemeClr val="tx1"/>
-                </a:solidFill>
-                <a:effectLst/>
-                <a:latin typeface="Arial" panose="020B0604020202020204" pitchFamily="34" charset="0"/>
-              </a:rPr>
-              <a:t> </a:t>
-            </a:r>
-          </a:p>
-          <a:p>
-            <a:pPr marL="0" marR="0" lvl="0" indent="0" algn="l" defTabSz="914400" rtl="0" eaLnBrk="0" fontAlgn="base" latinLnBrk="0" hangingPunct="0">
-              <a:lnSpc>
-                <a:spcPct val="100000"/>
-              </a:lnSpc>
-              <a:spcBef>
-                <a:spcPct val="0"/>
-              </a:spcBef>
-              <a:spcAft>
-                <a:spcPct val="0"/>
-              </a:spcAft>
-              <a:buClrTx/>
-              <a:buSzTx/>
-              <a:buFontTx/>
-              <a:buChar char="•"/>
-              <a:tabLst/>
-            </a:pPr>
-            <a:r>
-              <a:rPr kumimoji="0" lang="en-US" altLang="en-US" sz="1800" b="1" i="0" u="none" strike="noStrike" cap="none" normalizeH="0" baseline="0" dirty="0">
-                <a:ln>
-                  <a:noFill/>
-                </a:ln>
-                <a:solidFill>
-                  <a:schemeClr val="tx1"/>
-                </a:solidFill>
-                <a:effectLst/>
-                <a:latin typeface="Arial" panose="020B0604020202020204" pitchFamily="34" charset="0"/>
-              </a:rPr>
-              <a:t>Order Tracking System</a:t>
-            </a:r>
-            <a:br>
-              <a:rPr kumimoji="0" lang="en-US" altLang="en-US" sz="1800" b="0" i="0" u="none" strike="noStrike" cap="none" normalizeH="0" baseline="0" dirty="0">
-                <a:ln>
-                  <a:noFill/>
-                </a:ln>
-                <a:solidFill>
-                  <a:schemeClr val="tx1"/>
-                </a:solidFill>
-                <a:effectLst/>
-                <a:latin typeface="Arial" panose="020B0604020202020204" pitchFamily="34" charset="0"/>
-              </a:rPr>
-            </a:br>
-            <a:r>
-              <a:rPr kumimoji="0" lang="en-US" altLang="en-US" sz="1800" b="0" i="0" u="none" strike="noStrike" cap="none" normalizeH="0" baseline="0" dirty="0">
-                <a:ln>
-                  <a:noFill/>
-                </a:ln>
-                <a:solidFill>
-                  <a:schemeClr val="tx1"/>
-                </a:solidFill>
-                <a:effectLst/>
-                <a:latin typeface="Arial" panose="020B0604020202020204" pitchFamily="34" charset="0"/>
-              </a:rPr>
-              <a:t>Track order status after purchase </a:t>
-            </a:r>
-          </a:p>
-        </p:txBody>
-      </p:sp>
+      </p:pic>
     </p:spTree>
+    <p:extLst>
+      <p:ext uri="{BB962C8B-B14F-4D97-AF65-F5344CB8AC3E}">
+        <p14:creationId xmlns:p14="http://schemas.microsoft.com/office/powerpoint/2010/main" val="1939639584"/>
+      </p:ext>
+    </p:extLst>
   </p:cSld>
   <p:clrMapOvr>
     <a:masterClrMapping/>
@@ -5650,287 +6182,233 @@
       </p:grpSpPr>
       <p:sp>
         <p:nvSpPr>
-          <p:cNvPr id="77" name="Google Shape;46;p1"/>
-          <p:cNvSpPr txBox="1"/>
-          <p:nvPr/>
+          <p:cNvPr id="2" name="Title 1">
+            <a:extLst>
+              <a:ext uri="{FF2B5EF4-FFF2-40B4-BE49-F238E27FC236}">
+                <a16:creationId xmlns:a16="http://schemas.microsoft.com/office/drawing/2014/main" id="{5F3FF556-B4EB-6A67-CF8E-7DED7C81C79A}"/>
+              </a:ext>
+            </a:extLst>
+          </p:cNvPr>
+          <p:cNvSpPr>
+            <a:spLocks noGrp="1"/>
+          </p:cNvSpPr>
+          <p:nvPr>
+            <p:ph type="title"/>
+          </p:nvPr>
+        </p:nvSpPr>
+        <p:spPr/>
+        <p:txBody>
+          <a:bodyPr>
+            <a:normAutofit/>
+          </a:bodyPr>
+          <a:lstStyle/>
+          <a:p>
+            <a:r>
+              <a:rPr lang="en-US" sz="3500" b="1" dirty="0"/>
+              <a:t>Shop Section</a:t>
+            </a:r>
+            <a:endParaRPr lang="en-IN" sz="3500" b="1" dirty="0"/>
+          </a:p>
+        </p:txBody>
+      </p:sp>
+      <p:sp>
+        <p:nvSpPr>
+          <p:cNvPr id="3" name="Text Placeholder 2">
+            <a:extLst>
+              <a:ext uri="{FF2B5EF4-FFF2-40B4-BE49-F238E27FC236}">
+                <a16:creationId xmlns:a16="http://schemas.microsoft.com/office/drawing/2014/main" id="{708AEA9B-1525-820E-70EA-F043A6018A8D}"/>
+              </a:ext>
+            </a:extLst>
+          </p:cNvPr>
+          <p:cNvSpPr>
+            <a:spLocks noGrp="1"/>
+          </p:cNvSpPr>
+          <p:nvPr>
+            <p:ph type="body" idx="1"/>
+          </p:nvPr>
         </p:nvSpPr>
         <p:spPr>
           <a:xfrm>
-            <a:off x="502925" y="6414780"/>
-            <a:ext cx="2042150" cy="248265"/>
+            <a:off x="457200" y="1234440"/>
+            <a:ext cx="8229600" cy="4663123"/>
+          </a:xfrm>
+        </p:spPr>
+        <p:txBody>
+          <a:bodyPr/>
+          <a:lstStyle/>
+          <a:p>
+            <a:pPr marL="114300" indent="0">
+              <a:buNone/>
+            </a:pPr>
+            <a:endParaRPr lang="en-IN" dirty="0"/>
+          </a:p>
+        </p:txBody>
+      </p:sp>
+      <p:pic>
+        <p:nvPicPr>
+          <p:cNvPr id="5" name="Picture 4">
+            <a:extLst>
+              <a:ext uri="{FF2B5EF4-FFF2-40B4-BE49-F238E27FC236}">
+                <a16:creationId xmlns:a16="http://schemas.microsoft.com/office/drawing/2014/main" id="{5EB410E2-5F4B-49B3-1BBD-4B8AD6524212}"/>
+              </a:ext>
+            </a:extLst>
+          </p:cNvPr>
+          <p:cNvPicPr>
+            <a:picLocks noChangeAspect="1"/>
+          </p:cNvPicPr>
+          <p:nvPr/>
+        </p:nvPicPr>
+        <p:blipFill>
+          <a:blip r:embed="rId2">
+            <a:extLst>
+              <a:ext uri="{28A0092B-C50C-407E-A947-70E740481C1C}">
+                <a14:useLocalDpi xmlns:a14="http://schemas.microsoft.com/office/drawing/2010/main" val="0"/>
+              </a:ext>
+            </a:extLst>
+          </a:blip>
+          <a:stretch>
+            <a:fillRect/>
+          </a:stretch>
+        </p:blipFill>
+        <p:spPr>
+          <a:xfrm>
+            <a:off x="250020" y="1371601"/>
+            <a:ext cx="8493245" cy="4525962"/>
           </a:xfrm>
           <a:prstGeom prst="rect">
             <a:avLst/>
           </a:prstGeom>
-          <a:ln w="12700">
-            <a:miter lim="400000"/>
-          </a:ln>
-          <a:extLst>
-            <a:ext uri="{C572A759-6A51-4108-AA02-DFA0A04FC94B}">
-              <ma14:wrappingTextBoxFlag xmlns="" xmlns:m="http://schemas.openxmlformats.org/officeDocument/2006/math" xmlns:a14="http://schemas.microsoft.com/office/drawing/2010/main" xmlns:ma14="http://schemas.microsoft.com/office/mac/drawingml/2011/main" val="1"/>
-            </a:ext>
-          </a:extLst>
         </p:spPr>
+      </p:pic>
+    </p:spTree>
+    <p:extLst>
+      <p:ext uri="{BB962C8B-B14F-4D97-AF65-F5344CB8AC3E}">
+        <p14:creationId xmlns:p14="http://schemas.microsoft.com/office/powerpoint/2010/main" val="1975501070"/>
+      </p:ext>
+    </p:extLst>
+  </p:cSld>
+  <p:clrMapOvr>
+    <a:masterClrMapping/>
+  </p:clrMapOvr>
+  <p:transition spd="med"/>
+</p:sld>
+</file>
+
+<file path=ppt/slides/slide9.xml><?xml version="1.0" encoding="utf-8"?>
+<p:sld xmlns:a="http://schemas.openxmlformats.org/drawingml/2006/main" xmlns:r="http://schemas.openxmlformats.org/officeDocument/2006/relationships" xmlns:p="http://schemas.openxmlformats.org/presentationml/2006/main">
+  <p:cSld>
+    <p:spTree>
+      <p:nvGrpSpPr>
+        <p:cNvPr id="1" name=""/>
+        <p:cNvGrpSpPr/>
+        <p:nvPr/>
+      </p:nvGrpSpPr>
+      <p:grpSpPr>
+        <a:xfrm>
+          <a:off x="0" y="0"/>
+          <a:ext cx="0" cy="0"/>
+          <a:chOff x="0" y="0"/>
+          <a:chExt cx="0" cy="0"/>
+        </a:xfrm>
+      </p:grpSpPr>
+      <p:sp>
+        <p:nvSpPr>
+          <p:cNvPr id="2" name="Title 1">
+            <a:extLst>
+              <a:ext uri="{FF2B5EF4-FFF2-40B4-BE49-F238E27FC236}">
+                <a16:creationId xmlns:a16="http://schemas.microsoft.com/office/drawing/2014/main" id="{65844FDC-27DD-12CB-4F55-B29F04294E92}"/>
+              </a:ext>
+            </a:extLst>
+          </p:cNvPr>
+          <p:cNvSpPr>
+            <a:spLocks noGrp="1"/>
+          </p:cNvSpPr>
+          <p:nvPr>
+            <p:ph type="title"/>
+          </p:nvPr>
+        </p:nvSpPr>
+        <p:spPr/>
         <p:txBody>
-          <a:bodyPr lIns="45699" tIns="45699" rIns="45699" bIns="45699" anchor="ctr">
-            <a:spAutoFit/>
+          <a:bodyPr>
+            <a:normAutofit/>
           </a:bodyPr>
-          <a:lstStyle>
-            <a:lvl1pPr>
-              <a:defRPr sz="1200">
-                <a:solidFill>
-                  <a:srgbClr val="898989"/>
-                </a:solidFill>
-                <a:latin typeface="Calibri"/>
-                <a:ea typeface="Calibri"/>
-                <a:cs typeface="Calibri"/>
-                <a:sym typeface="Calibri"/>
-              </a:defRPr>
-            </a:lvl1pPr>
-          </a:lstStyle>
-          <a:p>
-            <a:r>
-              <a:t>22CS026</a:t>
-            </a:r>
+          <a:lstStyle/>
+          <a:p>
+            <a:r>
+              <a:rPr lang="en-US" sz="3600" b="1" dirty="0"/>
+              <a:t>Cart Section</a:t>
+            </a:r>
+            <a:endParaRPr lang="en-IN" sz="3600" b="1" dirty="0"/>
           </a:p>
         </p:txBody>
       </p:sp>
       <p:sp>
         <p:nvSpPr>
-          <p:cNvPr id="78" name="Google Shape;47;p1"/>
-          <p:cNvSpPr txBox="1">
+          <p:cNvPr id="3" name="Text Placeholder 2">
+            <a:extLst>
+              <a:ext uri="{FF2B5EF4-FFF2-40B4-BE49-F238E27FC236}">
+                <a16:creationId xmlns:a16="http://schemas.microsoft.com/office/drawing/2014/main" id="{8FB9866F-5D7E-FCBD-E20A-904B32819E35}"/>
+              </a:ext>
+            </a:extLst>
+          </p:cNvPr>
+          <p:cNvSpPr>
             <a:spLocks noGrp="1"/>
           </p:cNvSpPr>
           <p:nvPr>
-            <p:ph type="sldNum" sz="quarter" idx="2"/>
+            <p:ph type="body" idx="1"/>
           </p:nvPr>
         </p:nvSpPr>
+        <p:spPr/>
+        <p:txBody>
+          <a:bodyPr/>
+          <a:lstStyle/>
+          <a:p>
+            <a:endParaRPr lang="en-IN" dirty="0"/>
+          </a:p>
+        </p:txBody>
+      </p:sp>
+      <p:pic>
+        <p:nvPicPr>
+          <p:cNvPr id="5" name="Picture 4">
+            <a:extLst>
+              <a:ext uri="{FF2B5EF4-FFF2-40B4-BE49-F238E27FC236}">
+                <a16:creationId xmlns:a16="http://schemas.microsoft.com/office/drawing/2014/main" id="{4E9F0771-B4C7-FEF8-2B8E-9D4C077E8BBC}"/>
+              </a:ext>
+            </a:extLst>
+          </p:cNvPr>
+          <p:cNvPicPr>
+            <a:picLocks noChangeAspect="1"/>
+          </p:cNvPicPr>
+          <p:nvPr/>
+        </p:nvPicPr>
+        <p:blipFill>
+          <a:blip r:embed="rId2">
+            <a:extLst>
+              <a:ext uri="{28A0092B-C50C-407E-A947-70E740481C1C}">
+                <a14:useLocalDpi xmlns:a14="http://schemas.microsoft.com/office/drawing/2010/main" val="0"/>
+              </a:ext>
+            </a:extLst>
+          </a:blip>
+          <a:stretch>
+            <a:fillRect/>
+          </a:stretch>
+        </p:blipFill>
         <p:spPr>
           <a:xfrm>
-            <a:off x="8505458" y="6414780"/>
-            <a:ext cx="181343" cy="248265"/>
+            <a:off x="457200" y="1371600"/>
+            <a:ext cx="8275132" cy="4525962"/>
           </a:xfrm>
           <a:prstGeom prst="rect">
             <a:avLst/>
           </a:prstGeom>
-          <a:extLst>
-            <a:ext uri="{C572A759-6A51-4108-AA02-DFA0A04FC94B}">
-              <ma14:wrappingTextBoxFlag xmlns="" xmlns:m="http://schemas.openxmlformats.org/officeDocument/2006/math" xmlns:a14="http://schemas.microsoft.com/office/drawing/2010/main" xmlns:ma14="http://schemas.microsoft.com/office/mac/drawingml/2011/main" val="1"/>
-            </a:ext>
-          </a:extLst>
         </p:spPr>
-        <p:txBody>
-          <a:bodyPr/>
-          <a:lstStyle/>
-          <a:p>
-            <a:fld id="{86CB4B4D-7CA3-9044-876B-883B54F8677D}" type="slidenum">
-              <a:rPr/>
-              <a:t>8</a:t>
-            </a:fld>
-            <a:endParaRPr/>
-          </a:p>
-        </p:txBody>
-      </p:sp>
-      <p:sp>
-        <p:nvSpPr>
-          <p:cNvPr id="79" name="Google Shape;48;p1"/>
-          <p:cNvSpPr txBox="1"/>
-          <p:nvPr/>
-        </p:nvSpPr>
-        <p:spPr>
-          <a:xfrm>
-            <a:off x="58325" y="2338162"/>
-            <a:ext cx="9027350" cy="2872306"/>
-          </a:xfrm>
-          <a:prstGeom prst="rect">
-            <a:avLst/>
-          </a:prstGeom>
-          <a:ln w="12700">
-            <a:miter lim="400000"/>
-          </a:ln>
-          <a:extLst>
-            <a:ext uri="{C572A759-6A51-4108-AA02-DFA0A04FC94B}">
-              <ma14:wrappingTextBoxFlag xmlns="" xmlns:m="http://schemas.openxmlformats.org/officeDocument/2006/math" xmlns:a14="http://schemas.microsoft.com/office/drawing/2010/main" xmlns:ma14="http://schemas.microsoft.com/office/mac/drawingml/2011/main" val="1"/>
-            </a:ext>
-          </a:extLst>
-        </p:spPr>
-        <p:txBody>
-          <a:bodyPr lIns="33099" tIns="33099" rIns="33099" bIns="33099" anchor="ctr">
-            <a:spAutoFit/>
-          </a:bodyPr>
-          <a:lstStyle/>
-          <a:p>
-            <a:pPr algn="ctr">
-              <a:defRPr sz="3200" b="1">
-                <a:solidFill>
-                  <a:srgbClr val="FF0000"/>
-                </a:solidFill>
-              </a:defRPr>
-            </a:pPr>
-            <a:endParaRPr/>
-          </a:p>
-          <a:p>
-            <a:pPr algn="ctr">
-              <a:defRPr sz="3200" b="1">
-                <a:solidFill>
-                  <a:srgbClr val="FF0000"/>
-                </a:solidFill>
-              </a:defRPr>
-            </a:pPr>
-            <a:endParaRPr/>
-          </a:p>
-          <a:p>
-            <a:pPr algn="ctr">
-              <a:defRPr sz="3200" b="1">
-                <a:solidFill>
-                  <a:srgbClr val="FF0000"/>
-                </a:solidFill>
-              </a:defRPr>
-            </a:pPr>
-            <a:endParaRPr/>
-          </a:p>
-          <a:p>
-            <a:pPr algn="ctr">
-              <a:defRPr sz="3200" b="1">
-                <a:solidFill>
-                  <a:srgbClr val="FF0000"/>
-                </a:solidFill>
-              </a:defRPr>
-            </a:pPr>
-            <a:br/>
-            <a:endParaRPr/>
-          </a:p>
-        </p:txBody>
-      </p:sp>
-      <p:sp>
-        <p:nvSpPr>
-          <p:cNvPr id="80" name="TextBox 3"/>
-          <p:cNvSpPr txBox="1"/>
-          <p:nvPr/>
-        </p:nvSpPr>
-        <p:spPr>
-          <a:xfrm>
-            <a:off x="502924" y="1180469"/>
-            <a:ext cx="7926737" cy="4955203"/>
-          </a:xfrm>
-          <a:prstGeom prst="rect">
-            <a:avLst/>
-          </a:prstGeom>
-          <a:ln w="12700">
-            <a:miter lim="400000"/>
-          </a:ln>
-          <a:extLst>
-            <a:ext uri="{C572A759-6A51-4108-AA02-DFA0A04FC94B}">
-              <ma14:wrappingTextBoxFlag xmlns="" xmlns:m="http://schemas.openxmlformats.org/officeDocument/2006/math" xmlns:a14="http://schemas.microsoft.com/office/drawing/2010/main" xmlns:ma14="http://schemas.microsoft.com/office/mac/drawingml/2011/main" val="1"/>
-            </a:ext>
-          </a:extLst>
-        </p:spPr>
-        <p:txBody>
-          <a:bodyPr wrap="square" lIns="45719" rIns="45719">
-            <a:spAutoFit/>
-          </a:bodyPr>
-          <a:lstStyle/>
-          <a:p>
-            <a:pPr>
-              <a:defRPr sz="2800" b="1"/>
-            </a:pPr>
-            <a:r>
-              <a:rPr dirty="0"/>
-              <a:t>                         </a:t>
-            </a:r>
-            <a:r>
-              <a:rPr sz="3000" dirty="0"/>
-              <a:t>Conclusion</a:t>
-            </a:r>
-          </a:p>
-          <a:p>
-            <a:pPr>
-              <a:defRPr sz="2800" b="1"/>
-            </a:pPr>
-            <a:endParaRPr sz="3000" dirty="0"/>
-          </a:p>
-          <a:p>
-            <a:pPr>
-              <a:defRPr sz="2000" b="1"/>
-            </a:pPr>
-            <a:r>
-              <a:rPr dirty="0"/>
-              <a:t>Summary</a:t>
-            </a:r>
-            <a:r>
-              <a:rPr b="0" dirty="0"/>
-              <a:t>:</a:t>
-            </a:r>
-          </a:p>
-          <a:p>
-            <a:pPr>
-              <a:defRPr sz="1800"/>
-            </a:pPr>
-            <a:endParaRPr b="0" dirty="0"/>
-          </a:p>
-          <a:p>
-            <a:r>
-              <a:rPr lang="en-US" sz="2000" b="1" dirty="0"/>
-              <a:t>StyleCart</a:t>
-            </a:r>
-            <a:r>
-              <a:rPr lang="en-US" sz="2000" dirty="0"/>
-              <a:t> focuses on building a functional </a:t>
-            </a:r>
-            <a:r>
-              <a:rPr lang="en-US" sz="2000" b="1" dirty="0"/>
-              <a:t>e-commerce system </a:t>
-            </a:r>
-            <a:r>
-              <a:rPr lang="en-US" sz="2000" dirty="0"/>
-              <a:t>using </a:t>
-            </a:r>
-            <a:r>
-              <a:rPr lang="en-US" sz="2000" b="1" dirty="0"/>
-              <a:t>Django</a:t>
-            </a:r>
-            <a:r>
-              <a:rPr lang="en-US" sz="2000" dirty="0"/>
-              <a:t>.</a:t>
-            </a:r>
-          </a:p>
-          <a:p>
-            <a:endParaRPr lang="en-US" sz="2000" dirty="0"/>
-          </a:p>
-          <a:p>
-            <a:r>
-              <a:rPr lang="en-US" sz="2000" dirty="0"/>
-              <a:t>It demonstrates key features such as product browsing, cart management, and backend integration.</a:t>
-            </a:r>
-          </a:p>
-          <a:p>
-            <a:endParaRPr lang="en-US" sz="2000" dirty="0"/>
-          </a:p>
-          <a:p>
-            <a:r>
-              <a:rPr lang="en-US" sz="2000" dirty="0"/>
-              <a:t>The project provides hands-on experience in full-stack development and simulates real-world online shopping platforms.</a:t>
-            </a:r>
-          </a:p>
-          <a:p>
-            <a:pPr defTabSz="457200">
-              <a:spcBef>
-                <a:spcPts val="1200"/>
-              </a:spcBef>
-            </a:pPr>
-            <a:endParaRPr sz="2000" dirty="0"/>
-          </a:p>
-          <a:p>
-            <a:pPr lvl="1" indent="457200"/>
-            <a:endParaRPr dirty="0"/>
-          </a:p>
-          <a:p>
-            <a:pPr lvl="1" indent="457200"/>
-            <a:endParaRPr dirty="0"/>
-          </a:p>
-        </p:txBody>
-      </p:sp>
+      </p:pic>
     </p:spTree>
+    <p:extLst>
+      <p:ext uri="{BB962C8B-B14F-4D97-AF65-F5344CB8AC3E}">
+        <p14:creationId xmlns:p14="http://schemas.microsoft.com/office/powerpoint/2010/main" val="3057239693"/>
+      </p:ext>
+    </p:extLst>
   </p:cSld>
   <p:clrMapOvr>
     <a:masterClrMapping/>

</xml_diff>